<commit_message>
Finalize QA on Capítulos V and VII PowerPoint decks
Completes the QA pass (file validation, content check, full visual
render inspection) that was interrupted mid-run on both decks. Fixes
an "Actualidad" date-label wrapping defect on the Capítulo VII history
timeline slide; Capítulo V required no changes.
</commit_message>
<xml_diff>
--- a/presentaciones/Capitulo_VII_Intubacion_de_la_Traquea.pptx
+++ b/presentaciones/Capitulo_VII_Intubacion_de_la_Traquea.pptx
@@ -3784,30 +3784,7 @@
       </p:sp>
       <p:sp>
         <p:nvSpPr>
-          <p:cNvPr id="10" name="Shape 7"/>
-          <p:cNvSpPr/>
-          <p:nvPr/>
-        </p:nvSpPr>
-        <p:spPr>
-          <a:xfrm>
-            <a:off x="841248" y="4160520"/>
-            <a:ext cx="2194560" cy="0"/>
-          </a:xfrm>
-          <a:prstGeom prst="line">
-            <a:avLst/>
-          </a:prstGeom>
-          <a:noFill/>
-          <a:ln w="31750">
-            <a:solidFill>
-              <a:srgbClr val="17A2B8"/>
-            </a:solidFill>
-            <a:prstDash val="solid"/>
-          </a:ln>
-        </p:spPr>
-      </p:sp>
-      <p:sp>
-        <p:nvSpPr>
-          <p:cNvPr id="11" name="Text 8"/>
+          <p:cNvPr id="10" name="Text 7"/>
           <p:cNvSpPr txBox="1"/>
           <p:nvPr/>
         </p:nvSpPr>
@@ -3849,7 +3826,7 @@
       </p:sp>
       <p:sp>
         <p:nvSpPr>
-          <p:cNvPr id="12" name="Text 9"/>
+          <p:cNvPr id="11" name="Text 8"/>
           <p:cNvSpPr txBox="1"/>
           <p:nvPr/>
         </p:nvSpPr>
@@ -4016,8 +3993,8 @@
         </p:nvSpPr>
         <p:spPr>
           <a:xfrm>
-            <a:off x="1252728" y="603504"/>
-            <a:ext cx="9966960" cy="548640"/>
+            <a:off x="1252728" y="621792"/>
+            <a:ext cx="10195560" cy="548640"/>
           </a:xfrm>
           <a:prstGeom prst="rect">
             <a:avLst/>
@@ -4033,7 +4010,7 @@
               <a:buNone/>
             </a:pPr>
             <a:r>
-              <a:rPr lang="en-US" sz="2700" b="1" dirty="0">
+              <a:rPr lang="en-US" sz="2500" b="1" dirty="0">
                 <a:solidFill>
                   <a:srgbClr val="2C3E50"/>
                 </a:solidFill>
@@ -4043,7 +4020,7 @@
               </a:rPr>
               <a:t>Laringoscopios: hojas curvas y rectas</a:t>
             </a:r>
-            <a:endParaRPr lang="en-US" sz="2700" dirty="0"/>
+            <a:endParaRPr lang="en-US" sz="2500" dirty="0"/>
           </a:p>
         </p:txBody>
       </p:sp>
@@ -4771,8 +4748,8 @@
         </p:nvSpPr>
         <p:spPr>
           <a:xfrm>
-            <a:off x="1252728" y="603504"/>
-            <a:ext cx="9966960" cy="548640"/>
+            <a:off x="1252728" y="621792"/>
+            <a:ext cx="10195560" cy="548640"/>
           </a:xfrm>
           <a:prstGeom prst="rect">
             <a:avLst/>
@@ -4788,7 +4765,7 @@
               <a:buNone/>
             </a:pPr>
             <a:r>
-              <a:rPr lang="en-US" sz="2700" b="1" dirty="0">
+              <a:rPr lang="en-US" sz="2500" b="1" dirty="0">
                 <a:solidFill>
                   <a:srgbClr val="2C3E50"/>
                 </a:solidFill>
@@ -4796,9 +4773,9 @@
                 <a:ea typeface="Cambria" pitchFamily="34" charset="-122"/>
                 <a:cs typeface="Cambria" pitchFamily="34" charset="-120"/>
               </a:rPr>
-              <a:t>Tubos endotraqueales: tamaños y características</a:t>
-            </a:r>
-            <a:endParaRPr lang="en-US" sz="2700" dirty="0"/>
+              <a:t>Tubos endotraqueales</a:t>
+            </a:r>
+            <a:endParaRPr lang="en-US" sz="2500" dirty="0"/>
           </a:p>
         </p:txBody>
       </p:sp>
@@ -4859,8 +4836,8 @@
           </p:nvPr>
         </p:nvGraphicFramePr>
         <p:xfrm>
-          <a:off x="502920" y="1965960"/>
-          <a:ext cx="11201400" cy="2331720"/>
+          <a:off x="502920" y="1938528"/>
+          <a:ext cx="11201400" cy="2011680"/>
         </p:xfrm>
         <a:graphic>
           <a:graphicData uri="http://schemas.openxmlformats.org/drawingml/2006/table">
@@ -4869,10 +4846,10 @@
               <a:tblGrid>
                 <a:gridCol w="2468880"/>
                 <a:gridCol w="2788920"/>
-                <a:gridCol w="3108960"/>
-                <a:gridCol w="2834640"/>
+                <a:gridCol w="2377440"/>
+                <a:gridCol w="3566160"/>
               </a:tblGrid>
-              <a:tr h="388620">
+              <a:tr h="335280">
                 <a:tc>
                   <a:txBody>
                     <a:bodyPr/>
@@ -4882,7 +4859,7 @@
                         <a:buNone/>
                       </a:pPr>
                       <a:r>
-                        <a:rPr lang="en-US" sz="1200" b="1" dirty="0">
+                        <a:rPr lang="en-US" sz="1150" b="1" dirty="0">
                           <a:solidFill>
                             <a:srgbClr val="FFFFFF"/>
                           </a:solidFill>
@@ -4892,7 +4869,7 @@
                         </a:rPr>
                         <a:t>Paciente</a:t>
                       </a:r>
-                      <a:endParaRPr lang="en-US" sz="1200" dirty="0">
+                      <a:endParaRPr lang="en-US" sz="1150" dirty="0">
                         <a:latin typeface="Calibri" charset="0"/>
                         <a:ea typeface="Calibri" charset="0"/>
                         <a:cs typeface="Calibri" charset="0"/>
@@ -4950,7 +4927,7 @@
                         <a:buNone/>
                       </a:pPr>
                       <a:r>
-                        <a:rPr lang="en-US" sz="1200" b="1" dirty="0">
+                        <a:rPr lang="en-US" sz="1150" b="1" dirty="0">
                           <a:solidFill>
                             <a:srgbClr val="FFFFFF"/>
                           </a:solidFill>
@@ -4960,7 +4937,7 @@
                         </a:rPr>
                         <a:t>Diámetro interno (mm)</a:t>
                       </a:r>
-                      <a:endParaRPr lang="en-US" sz="1200" dirty="0">
+                      <a:endParaRPr lang="en-US" sz="1150" dirty="0">
                         <a:latin typeface="Calibri" charset="0"/>
                         <a:ea typeface="Calibri" charset="0"/>
                         <a:cs typeface="Calibri" charset="0"/>
@@ -5018,7 +4995,7 @@
                         <a:buNone/>
                       </a:pPr>
                       <a:r>
-                        <a:rPr lang="en-US" sz="1200" b="1" dirty="0">
+                        <a:rPr lang="en-US" sz="1150" b="1" dirty="0">
                           <a:solidFill>
                             <a:srgbClr val="FFFFFF"/>
                           </a:solidFill>
@@ -5026,9 +5003,9 @@
                           <a:ea typeface="Calibri" pitchFamily="34" charset="-122"/>
                           <a:cs typeface="Calibri" pitchFamily="34" charset="-120"/>
                         </a:rPr>
-                        <a:t>Profundidad aprox. (cm, comisura)</a:t>
+                        <a:t>Profundidad (cm)</a:t>
                       </a:r>
-                      <a:endParaRPr lang="en-US" sz="1200" dirty="0">
+                      <a:endParaRPr lang="en-US" sz="1150" dirty="0">
                         <a:latin typeface="Calibri" charset="0"/>
                         <a:ea typeface="Calibri" charset="0"/>
                         <a:cs typeface="Calibri" charset="0"/>
@@ -5086,7 +5063,7 @@
                         <a:buNone/>
                       </a:pPr>
                       <a:r>
-                        <a:rPr lang="en-US" sz="1200" b="1" dirty="0">
+                        <a:rPr lang="en-US" sz="1150" b="1" dirty="0">
                           <a:solidFill>
                             <a:srgbClr val="FFFFFF"/>
                           </a:solidFill>
@@ -5096,7 +5073,7 @@
                         </a:rPr>
                         <a:t>Balón (cuff)</a:t>
                       </a:r>
-                      <a:endParaRPr lang="en-US" sz="1200" dirty="0">
+                      <a:endParaRPr lang="en-US" sz="1150" dirty="0">
                         <a:latin typeface="Calibri" charset="0"/>
                         <a:ea typeface="Calibri" charset="0"/>
                         <a:cs typeface="Calibri" charset="0"/>
@@ -5146,7 +5123,7 @@
                   </a:tcPr>
                 </a:tc>
               </a:tr>
-              <a:tr h="388620">
+              <a:tr h="335280">
                 <a:tc>
                   <a:txBody>
                     <a:bodyPr/>
@@ -5156,7 +5133,7 @@
                         <a:buNone/>
                       </a:pPr>
                       <a:r>
-                        <a:rPr lang="en-US" sz="1200" dirty="0">
+                        <a:rPr lang="en-US" sz="1150" dirty="0">
                           <a:solidFill>
                             <a:srgbClr val="2C3E50"/>
                           </a:solidFill>
@@ -5166,7 +5143,7 @@
                         </a:rPr>
                         <a:t>Neonato</a:t>
                       </a:r>
-                      <a:endParaRPr lang="en-US" sz="1200" dirty="0">
+                      <a:endParaRPr lang="en-US" sz="1150" dirty="0">
                         <a:latin typeface="Calibri" charset="0"/>
                         <a:ea typeface="Calibri" charset="0"/>
                         <a:cs typeface="Calibri" charset="0"/>
@@ -5224,7 +5201,7 @@
                         <a:buNone/>
                       </a:pPr>
                       <a:r>
-                        <a:rPr lang="en-US" sz="1200" dirty="0">
+                        <a:rPr lang="en-US" sz="1150" dirty="0">
                           <a:solidFill>
                             <a:srgbClr val="2C3E50"/>
                           </a:solidFill>
@@ -5234,7 +5211,7 @@
                         </a:rPr>
                         <a:t>2.5 – 3.5</a:t>
                       </a:r>
-                      <a:endParaRPr lang="en-US" sz="1200" dirty="0">
+                      <a:endParaRPr lang="en-US" sz="1150" dirty="0">
                         <a:latin typeface="Calibri" charset="0"/>
                         <a:ea typeface="Calibri" charset="0"/>
                         <a:cs typeface="Calibri" charset="0"/>
@@ -5292,7 +5269,7 @@
                         <a:buNone/>
                       </a:pPr>
                       <a:r>
-                        <a:rPr lang="en-US" sz="1200" dirty="0">
+                        <a:rPr lang="en-US" sz="1150" dirty="0">
                           <a:solidFill>
                             <a:srgbClr val="2C3E50"/>
                           </a:solidFill>
@@ -5302,7 +5279,7 @@
                         </a:rPr>
                         <a:t>8 – 10</a:t>
                       </a:r>
-                      <a:endParaRPr lang="en-US" sz="1200" dirty="0">
+                      <a:endParaRPr lang="en-US" sz="1150" dirty="0">
                         <a:latin typeface="Calibri" charset="0"/>
                         <a:ea typeface="Calibri" charset="0"/>
                         <a:cs typeface="Calibri" charset="0"/>
@@ -5360,7 +5337,7 @@
                         <a:buNone/>
                       </a:pPr>
                       <a:r>
-                        <a:rPr lang="en-US" sz="1200" dirty="0">
+                        <a:rPr lang="en-US" sz="1150" dirty="0">
                           <a:solidFill>
                             <a:srgbClr val="2C3E50"/>
                           </a:solidFill>
@@ -5370,7 +5347,7 @@
                         </a:rPr>
                         <a:t>Habitualmente sin balón</a:t>
                       </a:r>
-                      <a:endParaRPr lang="en-US" sz="1200" dirty="0">
+                      <a:endParaRPr lang="en-US" sz="1150" dirty="0">
                         <a:latin typeface="Calibri" charset="0"/>
                         <a:ea typeface="Calibri" charset="0"/>
                         <a:cs typeface="Calibri" charset="0"/>
@@ -5420,7 +5397,7 @@
                   </a:tcPr>
                 </a:tc>
               </a:tr>
-              <a:tr h="388620">
+              <a:tr h="335280">
                 <a:tc>
                   <a:txBody>
                     <a:bodyPr/>
@@ -5430,7 +5407,7 @@
                         <a:buNone/>
                       </a:pPr>
                       <a:r>
-                        <a:rPr lang="en-US" sz="1200" dirty="0">
+                        <a:rPr lang="en-US" sz="1150" dirty="0">
                           <a:solidFill>
                             <a:srgbClr val="2C3E50"/>
                           </a:solidFill>
@@ -5440,7 +5417,7 @@
                         </a:rPr>
                         <a:t>Lactante (1-12 m)</a:t>
                       </a:r>
-                      <a:endParaRPr lang="en-US" sz="1200" dirty="0">
+                      <a:endParaRPr lang="en-US" sz="1150" dirty="0">
                         <a:latin typeface="Calibri" charset="0"/>
                         <a:ea typeface="Calibri" charset="0"/>
                         <a:cs typeface="Calibri" charset="0"/>
@@ -5498,7 +5475,7 @@
                         <a:buNone/>
                       </a:pPr>
                       <a:r>
-                        <a:rPr lang="en-US" sz="1200" dirty="0">
+                        <a:rPr lang="en-US" sz="1150" dirty="0">
                           <a:solidFill>
                             <a:srgbClr val="2C3E50"/>
                           </a:solidFill>
@@ -5508,7 +5485,7 @@
                         </a:rPr>
                         <a:t>3.5 – 4.0</a:t>
                       </a:r>
-                      <a:endParaRPr lang="en-US" sz="1200" dirty="0">
+                      <a:endParaRPr lang="en-US" sz="1150" dirty="0">
                         <a:latin typeface="Calibri" charset="0"/>
                         <a:ea typeface="Calibri" charset="0"/>
                         <a:cs typeface="Calibri" charset="0"/>
@@ -5566,7 +5543,7 @@
                         <a:buNone/>
                       </a:pPr>
                       <a:r>
-                        <a:rPr lang="en-US" sz="1200" dirty="0">
+                        <a:rPr lang="en-US" sz="1150" dirty="0">
                           <a:solidFill>
                             <a:srgbClr val="2C3E50"/>
                           </a:solidFill>
@@ -5576,7 +5553,7 @@
                         </a:rPr>
                         <a:t>10 – 12</a:t>
                       </a:r>
-                      <a:endParaRPr lang="en-US" sz="1200" dirty="0">
+                      <a:endParaRPr lang="en-US" sz="1150" dirty="0">
                         <a:latin typeface="Calibri" charset="0"/>
                         <a:ea typeface="Calibri" charset="0"/>
                         <a:cs typeface="Calibri" charset="0"/>
@@ -5634,7 +5611,7 @@
                         <a:buNone/>
                       </a:pPr>
                       <a:r>
-                        <a:rPr lang="en-US" sz="1200" dirty="0">
+                        <a:rPr lang="en-US" sz="1150" dirty="0">
                           <a:solidFill>
                             <a:srgbClr val="2C3E50"/>
                           </a:solidFill>
@@ -5642,9 +5619,9 @@
                           <a:ea typeface="Calibri" pitchFamily="34" charset="-122"/>
                           <a:cs typeface="Calibri" pitchFamily="34" charset="-120"/>
                         </a:rPr>
-                        <a:t>Sin balón o con balón de baja presión</a:t>
+                        <a:t>Sin balón / baja presión</a:t>
                       </a:r>
-                      <a:endParaRPr lang="en-US" sz="1200" dirty="0">
+                      <a:endParaRPr lang="en-US" sz="1150" dirty="0">
                         <a:latin typeface="Calibri" charset="0"/>
                         <a:ea typeface="Calibri" charset="0"/>
                         <a:cs typeface="Calibri" charset="0"/>
@@ -5694,7 +5671,7 @@
                   </a:tcPr>
                 </a:tc>
               </a:tr>
-              <a:tr h="388620">
+              <a:tr h="335280">
                 <a:tc>
                   <a:txBody>
                     <a:bodyPr/>
@@ -5704,7 +5681,7 @@
                         <a:buNone/>
                       </a:pPr>
                       <a:r>
-                        <a:rPr lang="en-US" sz="1200" dirty="0">
+                        <a:rPr lang="en-US" sz="1150" dirty="0">
                           <a:solidFill>
                             <a:srgbClr val="2C3E50"/>
                           </a:solidFill>
@@ -5714,7 +5691,7 @@
                         </a:rPr>
                         <a:t>Niño (edad/4 + 4)</a:t>
                       </a:r>
-                      <a:endParaRPr lang="en-US" sz="1200" dirty="0">
+                      <a:endParaRPr lang="en-US" sz="1150" dirty="0">
                         <a:latin typeface="Calibri" charset="0"/>
                         <a:ea typeface="Calibri" charset="0"/>
                         <a:cs typeface="Calibri" charset="0"/>
@@ -5772,7 +5749,7 @@
                         <a:buNone/>
                       </a:pPr>
                       <a:r>
-                        <a:rPr lang="en-US" sz="1200" dirty="0">
+                        <a:rPr lang="en-US" sz="1150" dirty="0">
                           <a:solidFill>
                             <a:srgbClr val="2C3E50"/>
                           </a:solidFill>
@@ -5782,7 +5759,7 @@
                         </a:rPr>
                         <a:t>4.5 – 6.0</a:t>
                       </a:r>
-                      <a:endParaRPr lang="en-US" sz="1200" dirty="0">
+                      <a:endParaRPr lang="en-US" sz="1150" dirty="0">
                         <a:latin typeface="Calibri" charset="0"/>
                         <a:ea typeface="Calibri" charset="0"/>
                         <a:cs typeface="Calibri" charset="0"/>
@@ -5840,7 +5817,7 @@
                         <a:buNone/>
                       </a:pPr>
                       <a:r>
-                        <a:rPr lang="en-US" sz="1200" dirty="0">
+                        <a:rPr lang="en-US" sz="1150" dirty="0">
                           <a:solidFill>
                             <a:srgbClr val="2C3E50"/>
                           </a:solidFill>
@@ -5850,7 +5827,7 @@
                         </a:rPr>
                         <a:t>Edad/2 + 12</a:t>
                       </a:r>
-                      <a:endParaRPr lang="en-US" sz="1200" dirty="0">
+                      <a:endParaRPr lang="en-US" sz="1150" dirty="0">
                         <a:latin typeface="Calibri" charset="0"/>
                         <a:ea typeface="Calibri" charset="0"/>
                         <a:cs typeface="Calibri" charset="0"/>
@@ -5908,7 +5885,7 @@
                         <a:buNone/>
                       </a:pPr>
                       <a:r>
-                        <a:rPr lang="en-US" sz="1200" dirty="0">
+                        <a:rPr lang="en-US" sz="1150" dirty="0">
                           <a:solidFill>
                             <a:srgbClr val="2C3E50"/>
                           </a:solidFill>
@@ -5916,9 +5893,9 @@
                           <a:ea typeface="Calibri" pitchFamily="34" charset="-122"/>
                           <a:cs typeface="Calibri" pitchFamily="34" charset="-120"/>
                         </a:rPr>
-                        <a:t>Según criterio (con o sin balón)</a:t>
+                        <a:t>Según criterio</a:t>
                       </a:r>
-                      <a:endParaRPr lang="en-US" sz="1200" dirty="0">
+                      <a:endParaRPr lang="en-US" sz="1150" dirty="0">
                         <a:latin typeface="Calibri" charset="0"/>
                         <a:ea typeface="Calibri" charset="0"/>
                         <a:cs typeface="Calibri" charset="0"/>
@@ -5968,7 +5945,7 @@
                   </a:tcPr>
                 </a:tc>
               </a:tr>
-              <a:tr h="388620">
+              <a:tr h="335280">
                 <a:tc>
                   <a:txBody>
                     <a:bodyPr/>
@@ -5978,7 +5955,7 @@
                         <a:buNone/>
                       </a:pPr>
                       <a:r>
-                        <a:rPr lang="en-US" sz="1200" dirty="0">
+                        <a:rPr lang="en-US" sz="1150" dirty="0">
                           <a:solidFill>
                             <a:srgbClr val="2C3E50"/>
                           </a:solidFill>
@@ -5988,7 +5965,7 @@
                         </a:rPr>
                         <a:t>Mujer adulta</a:t>
                       </a:r>
-                      <a:endParaRPr lang="en-US" sz="1200" dirty="0">
+                      <a:endParaRPr lang="en-US" sz="1150" dirty="0">
                         <a:latin typeface="Calibri" charset="0"/>
                         <a:ea typeface="Calibri" charset="0"/>
                         <a:cs typeface="Calibri" charset="0"/>
@@ -6046,7 +6023,7 @@
                         <a:buNone/>
                       </a:pPr>
                       <a:r>
-                        <a:rPr lang="en-US" sz="1200" dirty="0">
+                        <a:rPr lang="en-US" sz="1150" dirty="0">
                           <a:solidFill>
                             <a:srgbClr val="2C3E50"/>
                           </a:solidFill>
@@ -6056,7 +6033,7 @@
                         </a:rPr>
                         <a:t>6.5 – 7.5</a:t>
                       </a:r>
-                      <a:endParaRPr lang="en-US" sz="1200" dirty="0">
+                      <a:endParaRPr lang="en-US" sz="1150" dirty="0">
                         <a:latin typeface="Calibri" charset="0"/>
                         <a:ea typeface="Calibri" charset="0"/>
                         <a:cs typeface="Calibri" charset="0"/>
@@ -6114,7 +6091,7 @@
                         <a:buNone/>
                       </a:pPr>
                       <a:r>
-                        <a:rPr lang="en-US" sz="1200" dirty="0">
+                        <a:rPr lang="en-US" sz="1150" dirty="0">
                           <a:solidFill>
                             <a:srgbClr val="2C3E50"/>
                           </a:solidFill>
@@ -6124,7 +6101,7 @@
                         </a:rPr>
                         <a:t>21 – 23</a:t>
                       </a:r>
-                      <a:endParaRPr lang="en-US" sz="1200" dirty="0">
+                      <a:endParaRPr lang="en-US" sz="1150" dirty="0">
                         <a:latin typeface="Calibri" charset="0"/>
                         <a:ea typeface="Calibri" charset="0"/>
                         <a:cs typeface="Calibri" charset="0"/>
@@ -6182,7 +6159,7 @@
                         <a:buNone/>
                       </a:pPr>
                       <a:r>
-                        <a:rPr lang="en-US" sz="1200" dirty="0">
+                        <a:rPr lang="en-US" sz="1150" dirty="0">
                           <a:solidFill>
                             <a:srgbClr val="2C3E50"/>
                           </a:solidFill>
@@ -6190,9 +6167,9 @@
                           <a:ea typeface="Calibri" pitchFamily="34" charset="-122"/>
                           <a:cs typeface="Calibri" pitchFamily="34" charset="-120"/>
                         </a:rPr>
-                        <a:t>Con balón de alto volumen / baja presión</a:t>
+                        <a:t>Alto volumen / baja presión</a:t>
                       </a:r>
-                      <a:endParaRPr lang="en-US" sz="1200" dirty="0">
+                      <a:endParaRPr lang="en-US" sz="1150" dirty="0">
                         <a:latin typeface="Calibri" charset="0"/>
                         <a:ea typeface="Calibri" charset="0"/>
                         <a:cs typeface="Calibri" charset="0"/>
@@ -6242,7 +6219,7 @@
                   </a:tcPr>
                 </a:tc>
               </a:tr>
-              <a:tr h="388620">
+              <a:tr h="335280">
                 <a:tc>
                   <a:txBody>
                     <a:bodyPr/>
@@ -6252,7 +6229,7 @@
                         <a:buNone/>
                       </a:pPr>
                       <a:r>
-                        <a:rPr lang="en-US" sz="1200" dirty="0">
+                        <a:rPr lang="en-US" sz="1150" dirty="0">
                           <a:solidFill>
                             <a:srgbClr val="2C3E50"/>
                           </a:solidFill>
@@ -6262,7 +6239,7 @@
                         </a:rPr>
                         <a:t>Hombre adulto</a:t>
                       </a:r>
-                      <a:endParaRPr lang="en-US" sz="1200" dirty="0">
+                      <a:endParaRPr lang="en-US" sz="1150" dirty="0">
                         <a:latin typeface="Calibri" charset="0"/>
                         <a:ea typeface="Calibri" charset="0"/>
                         <a:cs typeface="Calibri" charset="0"/>
@@ -6320,7 +6297,7 @@
                         <a:buNone/>
                       </a:pPr>
                       <a:r>
-                        <a:rPr lang="en-US" sz="1200" dirty="0">
+                        <a:rPr lang="en-US" sz="1150" dirty="0">
                           <a:solidFill>
                             <a:srgbClr val="2C3E50"/>
                           </a:solidFill>
@@ -6330,7 +6307,7 @@
                         </a:rPr>
                         <a:t>7.5 – 8.5</a:t>
                       </a:r>
-                      <a:endParaRPr lang="en-US" sz="1200" dirty="0">
+                      <a:endParaRPr lang="en-US" sz="1150" dirty="0">
                         <a:latin typeface="Calibri" charset="0"/>
                         <a:ea typeface="Calibri" charset="0"/>
                         <a:cs typeface="Calibri" charset="0"/>
@@ -6388,7 +6365,7 @@
                         <a:buNone/>
                       </a:pPr>
                       <a:r>
-                        <a:rPr lang="en-US" sz="1200" dirty="0">
+                        <a:rPr lang="en-US" sz="1150" dirty="0">
                           <a:solidFill>
                             <a:srgbClr val="2C3E50"/>
                           </a:solidFill>
@@ -6398,7 +6375,7 @@
                         </a:rPr>
                         <a:t>23 – 25</a:t>
                       </a:r>
-                      <a:endParaRPr lang="en-US" sz="1200" dirty="0">
+                      <a:endParaRPr lang="en-US" sz="1150" dirty="0">
                         <a:latin typeface="Calibri" charset="0"/>
                         <a:ea typeface="Calibri" charset="0"/>
                         <a:cs typeface="Calibri" charset="0"/>
@@ -6456,7 +6433,7 @@
                         <a:buNone/>
                       </a:pPr>
                       <a:r>
-                        <a:rPr lang="en-US" sz="1200" dirty="0">
+                        <a:rPr lang="en-US" sz="1150" dirty="0">
                           <a:solidFill>
                             <a:srgbClr val="2C3E50"/>
                           </a:solidFill>
@@ -6464,9 +6441,9 @@
                           <a:ea typeface="Calibri" pitchFamily="34" charset="-122"/>
                           <a:cs typeface="Calibri" pitchFamily="34" charset="-120"/>
                         </a:rPr>
-                        <a:t>Con balón de alto volumen / baja presión</a:t>
+                        <a:t>Alto volumen / baja presión</a:t>
                       </a:r>
-                      <a:endParaRPr lang="en-US" sz="1200" dirty="0">
+                      <a:endParaRPr lang="en-US" sz="1150" dirty="0">
                         <a:latin typeface="Calibri" charset="0"/>
                         <a:ea typeface="Calibri" charset="0"/>
                         <a:cs typeface="Calibri" charset="0"/>
@@ -6528,12 +6505,12 @@
         </p:nvSpPr>
         <p:spPr>
           <a:xfrm>
-            <a:off x="502920" y="4526280"/>
-            <a:ext cx="5440680" cy="1417320"/>
+            <a:off x="502920" y="4279392"/>
+            <a:ext cx="5440680" cy="932688"/>
           </a:xfrm>
           <a:prstGeom prst="roundRect">
             <a:avLst>
-              <a:gd name="adj" fmla="val 5161"/>
+              <a:gd name="adj" fmla="val 6863"/>
             </a:avLst>
           </a:prstGeom>
           <a:solidFill>
@@ -6541,7 +6518,7 @@
           </a:solidFill>
           <a:ln/>
           <a:effectLst>
-            <a:outerShdw sx="100000" sy="100000" kx="0" ky="0" algn="bl" rotWithShape="0" blurRad="63500" dist="25400" dir="5400000">
+            <a:outerShdw sx="100000" sy="100000" kx="0" ky="0" algn="bl" rotWithShape="0" blurRad="50800" dist="25400" dir="5400000">
               <a:srgbClr val="1A2530">
                 <a:alpha val="12000"/>
               </a:srgbClr>
@@ -6557,24 +6534,24 @@
         </p:nvSpPr>
         <p:spPr>
           <a:xfrm>
-            <a:off x="731520" y="4709160"/>
-            <a:ext cx="4983480" cy="457200"/>
-          </a:xfrm>
-          <a:prstGeom prst="rect">
-            <a:avLst/>
-          </a:prstGeom>
-          <a:noFill/>
-          <a:ln/>
-        </p:spPr>
-        <p:txBody>
-          <a:bodyPr wrap="square" lIns="0" tIns="0" rIns="0" bIns="0" rtlCol="0" anchor="t"/>
+            <a:off x="704088" y="4370832"/>
+            <a:ext cx="5038344" cy="256032"/>
+          </a:xfrm>
+          <a:prstGeom prst="rect">
+            <a:avLst/>
+          </a:prstGeom>
+          <a:noFill/>
+          <a:ln/>
+        </p:spPr>
+        <p:txBody>
+          <a:bodyPr wrap="square" lIns="0" tIns="0" rIns="0" bIns="0" rtlCol="0" anchor="ctr"/>
           <a:lstStyle/>
           <a:p>
             <a:pPr indent="0" marL="0">
               <a:buNone/>
             </a:pPr>
             <a:r>
-              <a:rPr lang="en-US" sz="1350" b="1" dirty="0">
+              <a:rPr lang="en-US" sz="1250" b="1" dirty="0">
                 <a:solidFill>
                   <a:srgbClr val="2C3E50"/>
                 </a:solidFill>
@@ -6584,7 +6561,7 @@
               </a:rPr>
               <a:t>Balón (cuff)</a:t>
             </a:r>
-            <a:endParaRPr lang="en-US" sz="1350" dirty="0"/>
+            <a:endParaRPr lang="en-US" sz="1250" dirty="0"/>
           </a:p>
         </p:txBody>
       </p:sp>
@@ -6596,8 +6573,8 @@
         </p:nvSpPr>
         <p:spPr>
           <a:xfrm>
-            <a:off x="731520" y="5148072"/>
-            <a:ext cx="4983480" cy="658368"/>
+            <a:off x="704088" y="4645152"/>
+            <a:ext cx="5038344" cy="475488"/>
           </a:xfrm>
           <a:prstGeom prst="rect">
             <a:avLst/>
@@ -6611,15 +6588,12 @@
           <a:p>
             <a:pPr indent="0" marL="0">
               <a:lnSpc>
-                <a:spcPts val="1472"/>
+                <a:spcPts val="1250"/>
               </a:lnSpc>
-              <a:spcAft>
-                <a:spcPts val="600"/>
-              </a:spcAft>
-              <a:buNone/>
-            </a:pPr>
-            <a:r>
-              <a:rPr lang="en-US" sz="1150" dirty="0">
+              <a:buNone/>
+            </a:pPr>
+            <a:r>
+              <a:rPr lang="en-US" sz="1000" dirty="0">
                 <a:solidFill>
                   <a:srgbClr val="2C3E50"/>
                 </a:solidFill>
@@ -6627,9 +6601,9 @@
                 <a:ea typeface="Calibri" pitchFamily="34" charset="-122"/>
                 <a:cs typeface="Calibri" pitchFamily="34" charset="-120"/>
               </a:rPr>
-              <a:t>Sella la tráquea y minimiza la fuga aérea y el riesgo de aspiración; la presión debe mantenerse entre 20-30 cmH₂O para evitar isquemia de la mucosa.</a:t>
-            </a:r>
-            <a:endParaRPr lang="en-US" sz="1150" dirty="0"/>
+              <a:t>Sella la tráquea y minimiza la fuga aérea; la presión debe mantenerse entre 20-30 cmH₂O para evitar isquemia de la mucosa.</a:t>
+            </a:r>
+            <a:endParaRPr lang="en-US" sz="1000" dirty="0"/>
           </a:p>
         </p:txBody>
       </p:sp>
@@ -6641,12 +6615,12 @@
         </p:nvSpPr>
         <p:spPr>
           <a:xfrm>
-            <a:off x="6263640" y="4526280"/>
-            <a:ext cx="5440680" cy="1417320"/>
+            <a:off x="6263640" y="4279392"/>
+            <a:ext cx="5440680" cy="932688"/>
           </a:xfrm>
           <a:prstGeom prst="roundRect">
             <a:avLst>
-              <a:gd name="adj" fmla="val 5161"/>
+              <a:gd name="adj" fmla="val 6863"/>
             </a:avLst>
           </a:prstGeom>
           <a:solidFill>
@@ -6654,7 +6628,7 @@
           </a:solidFill>
           <a:ln/>
           <a:effectLst>
-            <a:outerShdw sx="100000" sy="100000" kx="0" ky="0" algn="bl" rotWithShape="0" blurRad="63500" dist="25400" dir="5400000">
+            <a:outerShdw sx="100000" sy="100000" kx="0" ky="0" algn="bl" rotWithShape="0" blurRad="50800" dist="25400" dir="5400000">
               <a:srgbClr val="1A2530">
                 <a:alpha val="12000"/>
               </a:srgbClr>
@@ -6670,24 +6644,24 @@
         </p:nvSpPr>
         <p:spPr>
           <a:xfrm>
-            <a:off x="6492240" y="4709160"/>
-            <a:ext cx="4983480" cy="457200"/>
-          </a:xfrm>
-          <a:prstGeom prst="rect">
-            <a:avLst/>
-          </a:prstGeom>
-          <a:noFill/>
-          <a:ln/>
-        </p:spPr>
-        <p:txBody>
-          <a:bodyPr wrap="square" lIns="0" tIns="0" rIns="0" bIns="0" rtlCol="0" anchor="t"/>
+            <a:off x="6464808" y="4370832"/>
+            <a:ext cx="5038344" cy="256032"/>
+          </a:xfrm>
+          <a:prstGeom prst="rect">
+            <a:avLst/>
+          </a:prstGeom>
+          <a:noFill/>
+          <a:ln/>
+        </p:spPr>
+        <p:txBody>
+          <a:bodyPr wrap="square" lIns="0" tIns="0" rIns="0" bIns="0" rtlCol="0" anchor="ctr"/>
           <a:lstStyle/>
           <a:p>
             <a:pPr indent="0" marL="0">
               <a:buNone/>
             </a:pPr>
             <a:r>
-              <a:rPr lang="en-US" sz="1350" b="1" dirty="0">
+              <a:rPr lang="en-US" sz="1250" b="1" dirty="0">
                 <a:solidFill>
                   <a:srgbClr val="2C3E50"/>
                 </a:solidFill>
@@ -6697,7 +6671,7 @@
               </a:rPr>
               <a:t>Línea radiopaca</a:t>
             </a:r>
-            <a:endParaRPr lang="en-US" sz="1350" dirty="0"/>
+            <a:endParaRPr lang="en-US" sz="1250" dirty="0"/>
           </a:p>
         </p:txBody>
       </p:sp>
@@ -6709,8 +6683,8 @@
         </p:nvSpPr>
         <p:spPr>
           <a:xfrm>
-            <a:off x="6492240" y="5148072"/>
-            <a:ext cx="4983480" cy="658368"/>
+            <a:off x="6464808" y="4645152"/>
+            <a:ext cx="5038344" cy="475488"/>
           </a:xfrm>
           <a:prstGeom prst="rect">
             <a:avLst/>
@@ -6724,15 +6698,12 @@
           <a:p>
             <a:pPr indent="0" marL="0">
               <a:lnSpc>
-                <a:spcPts val="1472"/>
+                <a:spcPts val="1250"/>
               </a:lnSpc>
-              <a:spcAft>
-                <a:spcPts val="600"/>
-              </a:spcAft>
-              <a:buNone/>
-            </a:pPr>
-            <a:r>
-              <a:rPr lang="en-US" sz="1150" dirty="0">
+              <a:buNone/>
+            </a:pPr>
+            <a:r>
+              <a:rPr lang="en-US" sz="1000" dirty="0">
                 <a:solidFill>
                   <a:srgbClr val="2C3E50"/>
                 </a:solidFill>
@@ -6742,7 +6713,7 @@
               </a:rPr>
               <a:t>Permite verificar la posición del tubo en la radiografía de tórax en pacientes de cuidados críticos.</a:t>
             </a:r>
-            <a:endParaRPr lang="en-US" sz="1150" dirty="0"/>
+            <a:endParaRPr lang="en-US" sz="1000" dirty="0"/>
           </a:p>
         </p:txBody>
       </p:sp>
@@ -6754,12 +6725,12 @@
         </p:nvSpPr>
         <p:spPr>
           <a:xfrm>
-            <a:off x="502920" y="4526280"/>
-            <a:ext cx="5440680" cy="1417320"/>
+            <a:off x="502920" y="5358384"/>
+            <a:ext cx="5440680" cy="932688"/>
           </a:xfrm>
           <a:prstGeom prst="roundRect">
             <a:avLst>
-              <a:gd name="adj" fmla="val 5161"/>
+              <a:gd name="adj" fmla="val 6863"/>
             </a:avLst>
           </a:prstGeom>
           <a:solidFill>
@@ -6767,7 +6738,7 @@
           </a:solidFill>
           <a:ln/>
           <a:effectLst>
-            <a:outerShdw sx="100000" sy="100000" kx="0" ky="0" algn="bl" rotWithShape="0" blurRad="63500" dist="25400" dir="5400000">
+            <a:outerShdw sx="100000" sy="100000" kx="0" ky="0" algn="bl" rotWithShape="0" blurRad="50800" dist="25400" dir="5400000">
               <a:srgbClr val="1A2530">
                 <a:alpha val="12000"/>
               </a:srgbClr>
@@ -6783,24 +6754,24 @@
         </p:nvSpPr>
         <p:spPr>
           <a:xfrm>
-            <a:off x="731520" y="4709160"/>
-            <a:ext cx="4983480" cy="457200"/>
-          </a:xfrm>
-          <a:prstGeom prst="rect">
-            <a:avLst/>
-          </a:prstGeom>
-          <a:noFill/>
-          <a:ln/>
-        </p:spPr>
-        <p:txBody>
-          <a:bodyPr wrap="square" lIns="0" tIns="0" rIns="0" bIns="0" rtlCol="0" anchor="t"/>
+            <a:off x="704088" y="5449824"/>
+            <a:ext cx="5038344" cy="256032"/>
+          </a:xfrm>
+          <a:prstGeom prst="rect">
+            <a:avLst/>
+          </a:prstGeom>
+          <a:noFill/>
+          <a:ln/>
+        </p:spPr>
+        <p:txBody>
+          <a:bodyPr wrap="square" lIns="0" tIns="0" rIns="0" bIns="0" rtlCol="0" anchor="ctr"/>
           <a:lstStyle/>
           <a:p>
             <a:pPr indent="0" marL="0">
               <a:buNone/>
             </a:pPr>
             <a:r>
-              <a:rPr lang="en-US" sz="1350" b="1" dirty="0">
+              <a:rPr lang="en-US" sz="1250" b="1" dirty="0">
                 <a:solidFill>
                   <a:srgbClr val="2C3E50"/>
                 </a:solidFill>
@@ -6810,7 +6781,7 @@
               </a:rPr>
               <a:t>Marcas de profundidad</a:t>
             </a:r>
-            <a:endParaRPr lang="en-US" sz="1350" dirty="0"/>
+            <a:endParaRPr lang="en-US" sz="1250" dirty="0"/>
           </a:p>
         </p:txBody>
       </p:sp>
@@ -6822,8 +6793,8 @@
         </p:nvSpPr>
         <p:spPr>
           <a:xfrm>
-            <a:off x="731520" y="5148072"/>
-            <a:ext cx="4983480" cy="658368"/>
+            <a:off x="704088" y="5724144"/>
+            <a:ext cx="5038344" cy="475488"/>
           </a:xfrm>
           <a:prstGeom prst="rect">
             <a:avLst/>
@@ -6837,15 +6808,12 @@
           <a:p>
             <a:pPr indent="0" marL="0">
               <a:lnSpc>
-                <a:spcPts val="1472"/>
+                <a:spcPts val="1250"/>
               </a:lnSpc>
-              <a:spcAft>
-                <a:spcPts val="600"/>
-              </a:spcAft>
-              <a:buNone/>
-            </a:pPr>
-            <a:r>
-              <a:rPr lang="en-US" sz="1150" dirty="0">
+              <a:buNone/>
+            </a:pPr>
+            <a:r>
+              <a:rPr lang="en-US" sz="1000" dirty="0">
                 <a:solidFill>
                   <a:srgbClr val="2C3E50"/>
                 </a:solidFill>
@@ -6855,7 +6823,7 @@
               </a:rPr>
               <a:t>Referencia en centímetros desde la punta distal, útil para fijar el tubo a la altura correcta en la arcada dentaria.</a:t>
             </a:r>
-            <a:endParaRPr lang="en-US" sz="1150" dirty="0"/>
+            <a:endParaRPr lang="en-US" sz="1000" dirty="0"/>
           </a:p>
         </p:txBody>
       </p:sp>
@@ -6867,12 +6835,12 @@
         </p:nvSpPr>
         <p:spPr>
           <a:xfrm>
-            <a:off x="6263640" y="4526280"/>
-            <a:ext cx="5440680" cy="1417320"/>
+            <a:off x="6263640" y="5358384"/>
+            <a:ext cx="5440680" cy="932688"/>
           </a:xfrm>
           <a:prstGeom prst="roundRect">
             <a:avLst>
-              <a:gd name="adj" fmla="val 5161"/>
+              <a:gd name="adj" fmla="val 6863"/>
             </a:avLst>
           </a:prstGeom>
           <a:solidFill>
@@ -6880,7 +6848,7 @@
           </a:solidFill>
           <a:ln/>
           <a:effectLst>
-            <a:outerShdw sx="100000" sy="100000" kx="0" ky="0" algn="bl" rotWithShape="0" blurRad="63500" dist="25400" dir="5400000">
+            <a:outerShdw sx="100000" sy="100000" kx="0" ky="0" algn="bl" rotWithShape="0" blurRad="50800" dist="25400" dir="5400000">
               <a:srgbClr val="1A2530">
                 <a:alpha val="12000"/>
               </a:srgbClr>
@@ -6896,24 +6864,24 @@
         </p:nvSpPr>
         <p:spPr>
           <a:xfrm>
-            <a:off x="6492240" y="4709160"/>
-            <a:ext cx="4983480" cy="457200"/>
-          </a:xfrm>
-          <a:prstGeom prst="rect">
-            <a:avLst/>
-          </a:prstGeom>
-          <a:noFill/>
-          <a:ln/>
-        </p:spPr>
-        <p:txBody>
-          <a:bodyPr wrap="square" lIns="0" tIns="0" rIns="0" bIns="0" rtlCol="0" anchor="t"/>
+            <a:off x="6464808" y="5449824"/>
+            <a:ext cx="5038344" cy="256032"/>
+          </a:xfrm>
+          <a:prstGeom prst="rect">
+            <a:avLst/>
+          </a:prstGeom>
+          <a:noFill/>
+          <a:ln/>
+        </p:spPr>
+        <p:txBody>
+          <a:bodyPr wrap="square" lIns="0" tIns="0" rIns="0" bIns="0" rtlCol="0" anchor="ctr"/>
           <a:lstStyle/>
           <a:p>
             <a:pPr indent="0" marL="0">
               <a:buNone/>
             </a:pPr>
             <a:r>
-              <a:rPr lang="en-US" sz="1350" b="1" dirty="0">
+              <a:rPr lang="en-US" sz="1250" b="1" dirty="0">
                 <a:solidFill>
                   <a:srgbClr val="2C3E50"/>
                 </a:solidFill>
@@ -6923,7 +6891,7 @@
               </a:rPr>
               <a:t>Tubos especiales</a:t>
             </a:r>
-            <a:endParaRPr lang="en-US" sz="1350" dirty="0"/>
+            <a:endParaRPr lang="en-US" sz="1250" dirty="0"/>
           </a:p>
         </p:txBody>
       </p:sp>
@@ -6935,8 +6903,8 @@
         </p:nvSpPr>
         <p:spPr>
           <a:xfrm>
-            <a:off x="6492240" y="5148072"/>
-            <a:ext cx="4983480" cy="658368"/>
+            <a:off x="6464808" y="5724144"/>
+            <a:ext cx="5038344" cy="475488"/>
           </a:xfrm>
           <a:prstGeom prst="rect">
             <a:avLst/>
@@ -6950,15 +6918,12 @@
           <a:p>
             <a:pPr indent="0" marL="0">
               <a:lnSpc>
-                <a:spcPts val="1472"/>
+                <a:spcPts val="1250"/>
               </a:lnSpc>
-              <a:spcAft>
-                <a:spcPts val="600"/>
-              </a:spcAft>
-              <a:buNone/>
-            </a:pPr>
-            <a:r>
-              <a:rPr lang="en-US" sz="1150" dirty="0">
+              <a:buNone/>
+            </a:pPr>
+            <a:r>
+              <a:rPr lang="en-US" sz="1000" dirty="0">
                 <a:solidFill>
                   <a:srgbClr val="2C3E50"/>
                 </a:solidFill>
@@ -6966,9 +6931,9 @@
                 <a:ea typeface="Calibri" pitchFamily="34" charset="-122"/>
                 <a:cs typeface="Calibri" pitchFamily="34" charset="-120"/>
               </a:rPr>
-              <a:t>Reforzados (anillados), RAE (preformados naso/orales), de doble luz (cirugía torácica) y con lumen para aspiración subglótica.</a:t>
-            </a:r>
-            <a:endParaRPr lang="en-US" sz="1150" dirty="0"/>
+              <a:t>Reforzados (anillados), RAE (preformados), de doble luz (cirugía torácica) y con lumen para aspiración subglótica.</a:t>
+            </a:r>
+            <a:endParaRPr lang="en-US" sz="1000" dirty="0"/>
           </a:p>
         </p:txBody>
       </p:sp>
@@ -7180,8 +7145,8 @@
         </p:nvSpPr>
         <p:spPr>
           <a:xfrm>
-            <a:off x="1252728" y="603504"/>
-            <a:ext cx="9966960" cy="548640"/>
+            <a:off x="1252728" y="621792"/>
+            <a:ext cx="10195560" cy="548640"/>
           </a:xfrm>
           <a:prstGeom prst="rect">
             <a:avLst/>
@@ -7197,7 +7162,7 @@
               <a:buNone/>
             </a:pPr>
             <a:r>
-              <a:rPr lang="en-US" sz="2700" b="1" dirty="0">
+              <a:rPr lang="en-US" sz="2500" b="1" dirty="0">
                 <a:solidFill>
                   <a:srgbClr val="2C3E50"/>
                 </a:solidFill>
@@ -7207,7 +7172,7 @@
               </a:rPr>
               <a:t>Dispositivos supraglóticos y accesorios</a:t>
             </a:r>
-            <a:endParaRPr lang="en-US" sz="2700" dirty="0"/>
+            <a:endParaRPr lang="en-US" sz="2500" dirty="0"/>
           </a:p>
         </p:txBody>
       </p:sp>
@@ -7338,8 +7303,8 @@
         </p:nvSpPr>
         <p:spPr>
           <a:xfrm>
-            <a:off x="1289304" y="2130552"/>
-            <a:ext cx="2624328" cy="1207008"/>
+            <a:off x="1289304" y="2112264"/>
+            <a:ext cx="2624328" cy="1225296"/>
           </a:xfrm>
           <a:prstGeom prst="rect">
             <a:avLst/>
@@ -7502,8 +7467,8 @@
         </p:nvSpPr>
         <p:spPr>
           <a:xfrm>
-            <a:off x="5020056" y="2130552"/>
-            <a:ext cx="2624328" cy="1207008"/>
+            <a:off x="5020056" y="2386584"/>
+            <a:ext cx="2624328" cy="950976"/>
           </a:xfrm>
           <a:prstGeom prst="rect">
             <a:avLst/>
@@ -7666,8 +7631,8 @@
         </p:nvSpPr>
         <p:spPr>
           <a:xfrm>
-            <a:off x="8750808" y="2130552"/>
-            <a:ext cx="2624328" cy="1207008"/>
+            <a:off x="8750808" y="2112264"/>
+            <a:ext cx="2624328" cy="1225296"/>
           </a:xfrm>
           <a:prstGeom prst="rect">
             <a:avLst/>
@@ -7830,8 +7795,8 @@
         </p:nvSpPr>
         <p:spPr>
           <a:xfrm>
-            <a:off x="1289304" y="4279392"/>
-            <a:ext cx="2624328" cy="1207008"/>
+            <a:off x="1289304" y="4261104"/>
+            <a:ext cx="2624328" cy="1225296"/>
           </a:xfrm>
           <a:prstGeom prst="rect">
             <a:avLst/>
@@ -7994,8 +7959,8 @@
         </p:nvSpPr>
         <p:spPr>
           <a:xfrm>
-            <a:off x="5020056" y="4279392"/>
-            <a:ext cx="2624328" cy="1207008"/>
+            <a:off x="5020056" y="4261104"/>
+            <a:ext cx="2624328" cy="1225296"/>
           </a:xfrm>
           <a:prstGeom prst="rect">
             <a:avLst/>
@@ -8158,8 +8123,8 @@
         </p:nvSpPr>
         <p:spPr>
           <a:xfrm>
-            <a:off x="8750808" y="4279392"/>
-            <a:ext cx="2624328" cy="1207008"/>
+            <a:off x="8750808" y="4535424"/>
+            <a:ext cx="2624328" cy="950976"/>
           </a:xfrm>
           <a:prstGeom prst="rect">
             <a:avLst/>
@@ -8403,8 +8368,8 @@
         </p:nvSpPr>
         <p:spPr>
           <a:xfrm>
-            <a:off x="1252728" y="603504"/>
-            <a:ext cx="9966960" cy="548640"/>
+            <a:off x="1252728" y="621792"/>
+            <a:ext cx="10195560" cy="548640"/>
           </a:xfrm>
           <a:prstGeom prst="rect">
             <a:avLst/>
@@ -8420,7 +8385,7 @@
               <a:buNone/>
             </a:pPr>
             <a:r>
-              <a:rPr lang="en-US" sz="2700" b="1" dirty="0">
+              <a:rPr lang="en-US" sz="2500" b="1" dirty="0">
                 <a:solidFill>
                   <a:srgbClr val="2C3E50"/>
                 </a:solidFill>
@@ -8428,9 +8393,9 @@
                 <a:ea typeface="Cambria" pitchFamily="34" charset="-122"/>
                 <a:cs typeface="Cambria" pitchFamily="34" charset="-120"/>
               </a:rPr>
-              <a:t>Succión, capnografía y confirmación de la vía aérea</a:t>
-            </a:r>
-            <a:endParaRPr lang="en-US" sz="2700" dirty="0"/>
+              <a:t>Succión, capnografía y confirmación</a:t>
+            </a:r>
+            <a:endParaRPr lang="en-US" sz="2500" dirty="0"/>
           </a:p>
         </p:txBody>
       </p:sp>
@@ -8561,8 +8526,8 @@
         </p:nvSpPr>
         <p:spPr>
           <a:xfrm>
-            <a:off x="1289304" y="2130552"/>
-            <a:ext cx="4425696" cy="1389888"/>
+            <a:off x="1289304" y="2112264"/>
+            <a:ext cx="4425696" cy="1408176"/>
           </a:xfrm>
           <a:prstGeom prst="rect">
             <a:avLst/>
@@ -8774,8 +8739,8 @@
         </p:nvSpPr>
         <p:spPr>
           <a:xfrm>
-            <a:off x="1289304" y="4416552"/>
-            <a:ext cx="4425696" cy="1527048"/>
+            <a:off x="1289304" y="4398264"/>
+            <a:ext cx="4425696" cy="1545336"/>
           </a:xfrm>
           <a:prstGeom prst="rect">
             <a:avLst/>
@@ -8914,8 +8879,8 @@
         </p:nvSpPr>
         <p:spPr>
           <a:xfrm>
-            <a:off x="6172200" y="1618488"/>
-            <a:ext cx="5440680" cy="981151"/>
+            <a:off x="6172200" y="1600200"/>
+            <a:ext cx="5440680" cy="778154"/>
           </a:xfrm>
           <a:prstGeom prst="rect">
             <a:avLst/>
@@ -8953,8 +8918,8 @@
         </p:nvSpPr>
         <p:spPr>
           <a:xfrm>
-            <a:off x="6309360" y="2523744"/>
-            <a:ext cx="5166360" cy="642823"/>
+            <a:off x="6309360" y="2388413"/>
+            <a:ext cx="5166360" cy="744322"/>
           </a:xfrm>
           <a:prstGeom prst="rect">
             <a:avLst/>
@@ -9114,8 +9079,8 @@
         </p:nvSpPr>
         <p:spPr>
           <a:xfrm>
-            <a:off x="6958584" y="4005072"/>
-            <a:ext cx="4471416" cy="1938528"/>
+            <a:off x="6958584" y="3986784"/>
+            <a:ext cx="4471416" cy="1956816"/>
           </a:xfrm>
           <a:prstGeom prst="rect">
             <a:avLst/>
@@ -9432,8 +9397,8 @@
         </p:nvSpPr>
         <p:spPr>
           <a:xfrm>
-            <a:off x="1252728" y="603504"/>
-            <a:ext cx="9966960" cy="548640"/>
+            <a:off x="1252728" y="621792"/>
+            <a:ext cx="10195560" cy="548640"/>
           </a:xfrm>
           <a:prstGeom prst="rect">
             <a:avLst/>
@@ -9449,7 +9414,7 @@
               <a:buNone/>
             </a:pPr>
             <a:r>
-              <a:rPr lang="en-US" sz="2700" b="1" dirty="0">
+              <a:rPr lang="en-US" sz="2500" b="1" dirty="0">
                 <a:solidFill>
                   <a:srgbClr val="2C3E50"/>
                 </a:solidFill>
@@ -9459,7 +9424,7 @@
               </a:rPr>
               <a:t>Predictores clínicos de vía aérea difícil</a:t>
             </a:r>
-            <a:endParaRPr lang="en-US" sz="2700" dirty="0"/>
+            <a:endParaRPr lang="en-US" sz="2500" dirty="0"/>
           </a:p>
         </p:txBody>
       </p:sp>
@@ -11425,8 +11390,8 @@
         </p:nvSpPr>
         <p:spPr>
           <a:xfrm>
-            <a:off x="1252728" y="603504"/>
-            <a:ext cx="9966960" cy="548640"/>
+            <a:off x="1252728" y="621792"/>
+            <a:ext cx="10195560" cy="548640"/>
           </a:xfrm>
           <a:prstGeom prst="rect">
             <a:avLst/>
@@ -11442,7 +11407,7 @@
               <a:buNone/>
             </a:pPr>
             <a:r>
-              <a:rPr lang="en-US" sz="2700" b="1" dirty="0">
+              <a:rPr lang="en-US" sz="2500" b="1" dirty="0">
                 <a:solidFill>
                   <a:srgbClr val="2C3E50"/>
                 </a:solidFill>
@@ -11452,7 +11417,7 @@
               </a:rPr>
               <a:t>Preparación del paciente y preoxigenación</a:t>
             </a:r>
-            <a:endParaRPr lang="en-US" sz="2700" dirty="0"/>
+            <a:endParaRPr lang="en-US" sz="2500" dirty="0"/>
           </a:p>
         </p:txBody>
       </p:sp>
@@ -11464,8 +11429,8 @@
         </p:nvSpPr>
         <p:spPr>
           <a:xfrm>
-            <a:off x="502920" y="2103120"/>
-            <a:ext cx="777240" cy="777240"/>
+            <a:off x="1257300" y="1965960"/>
+            <a:ext cx="731520" cy="731520"/>
           </a:xfrm>
           <a:prstGeom prst="ellipse">
             <a:avLst/>
@@ -11491,8 +11456,8 @@
         </p:nvSpPr>
         <p:spPr>
           <a:xfrm>
-            <a:off x="502920" y="2103120"/>
-            <a:ext cx="777240" cy="777240"/>
+            <a:off x="1257300" y="1965960"/>
+            <a:ext cx="731520" cy="731520"/>
           </a:xfrm>
           <a:prstGeom prst="rect">
             <a:avLst/>
@@ -11530,8 +11495,8 @@
         </p:nvSpPr>
         <p:spPr>
           <a:xfrm>
-            <a:off x="-342900" y="2990088"/>
-            <a:ext cx="2468880" cy="320040"/>
+            <a:off x="557784" y="2807208"/>
+            <a:ext cx="2130552" cy="320040"/>
           </a:xfrm>
           <a:prstGeom prst="rect">
             <a:avLst/>
@@ -11569,8 +11534,8 @@
         </p:nvSpPr>
         <p:spPr>
           <a:xfrm>
-            <a:off x="-342900" y="3300984"/>
-            <a:ext cx="2468880" cy="822960"/>
+            <a:off x="557784" y="3118104"/>
+            <a:ext cx="2130552" cy="822960"/>
           </a:xfrm>
           <a:prstGeom prst="rect">
             <a:avLst/>
@@ -11611,8 +11576,8 @@
         </p:nvSpPr>
         <p:spPr>
           <a:xfrm>
-            <a:off x="1335024" y="2409444"/>
-            <a:ext cx="1719072" cy="164592"/>
+            <a:off x="2043684" y="2249424"/>
+            <a:ext cx="1399032" cy="164592"/>
           </a:xfrm>
           <a:prstGeom prst="rightArrow">
             <a:avLst/>
@@ -11631,8 +11596,8 @@
         </p:nvSpPr>
         <p:spPr>
           <a:xfrm>
-            <a:off x="3108960" y="2103120"/>
-            <a:ext cx="777240" cy="777240"/>
+            <a:off x="3497580" y="1965960"/>
+            <a:ext cx="731520" cy="731520"/>
           </a:xfrm>
           <a:prstGeom prst="ellipse">
             <a:avLst/>
@@ -11658,8 +11623,8 @@
         </p:nvSpPr>
         <p:spPr>
           <a:xfrm>
-            <a:off x="3108960" y="2103120"/>
-            <a:ext cx="777240" cy="777240"/>
+            <a:off x="3497580" y="1965960"/>
+            <a:ext cx="731520" cy="731520"/>
           </a:xfrm>
           <a:prstGeom prst="rect">
             <a:avLst/>
@@ -11697,8 +11662,8 @@
         </p:nvSpPr>
         <p:spPr>
           <a:xfrm>
-            <a:off x="2263140" y="2990088"/>
-            <a:ext cx="2468880" cy="320040"/>
+            <a:off x="2798064" y="2807208"/>
+            <a:ext cx="2130552" cy="320040"/>
           </a:xfrm>
           <a:prstGeom prst="rect">
             <a:avLst/>
@@ -11736,8 +11701,8 @@
         </p:nvSpPr>
         <p:spPr>
           <a:xfrm>
-            <a:off x="2263140" y="3300984"/>
-            <a:ext cx="2468880" cy="822960"/>
+            <a:off x="2798064" y="3118104"/>
+            <a:ext cx="2130552" cy="822960"/>
           </a:xfrm>
           <a:prstGeom prst="rect">
             <a:avLst/>
@@ -11778,8 +11743,8 @@
         </p:nvSpPr>
         <p:spPr>
           <a:xfrm>
-            <a:off x="3941064" y="2409444"/>
-            <a:ext cx="1719072" cy="164592"/>
+            <a:off x="4283964" y="2249424"/>
+            <a:ext cx="1399032" cy="164592"/>
           </a:xfrm>
           <a:prstGeom prst="rightArrow">
             <a:avLst/>
@@ -11798,8 +11763,8 @@
         </p:nvSpPr>
         <p:spPr>
           <a:xfrm>
-            <a:off x="5715000" y="2103120"/>
-            <a:ext cx="777240" cy="777240"/>
+            <a:off x="5737860" y="1965960"/>
+            <a:ext cx="731520" cy="731520"/>
           </a:xfrm>
           <a:prstGeom prst="ellipse">
             <a:avLst/>
@@ -11825,8 +11790,8 @@
         </p:nvSpPr>
         <p:spPr>
           <a:xfrm>
-            <a:off x="5715000" y="2103120"/>
-            <a:ext cx="777240" cy="777240"/>
+            <a:off x="5737860" y="1965960"/>
+            <a:ext cx="731520" cy="731520"/>
           </a:xfrm>
           <a:prstGeom prst="rect">
             <a:avLst/>
@@ -11864,8 +11829,8 @@
         </p:nvSpPr>
         <p:spPr>
           <a:xfrm>
-            <a:off x="4869180" y="2990088"/>
-            <a:ext cx="2468880" cy="320040"/>
+            <a:off x="5038344" y="2807208"/>
+            <a:ext cx="2130552" cy="320040"/>
           </a:xfrm>
           <a:prstGeom prst="rect">
             <a:avLst/>
@@ -11903,8 +11868,8 @@
         </p:nvSpPr>
         <p:spPr>
           <a:xfrm>
-            <a:off x="4869180" y="3300984"/>
-            <a:ext cx="2468880" cy="822960"/>
+            <a:off x="5038344" y="3118104"/>
+            <a:ext cx="2130552" cy="822960"/>
           </a:xfrm>
           <a:prstGeom prst="rect">
             <a:avLst/>
@@ -11945,8 +11910,8 @@
         </p:nvSpPr>
         <p:spPr>
           <a:xfrm>
-            <a:off x="6547104" y="2409444"/>
-            <a:ext cx="1719072" cy="164592"/>
+            <a:off x="6524244" y="2249424"/>
+            <a:ext cx="1399032" cy="164592"/>
           </a:xfrm>
           <a:prstGeom prst="rightArrow">
             <a:avLst/>
@@ -11965,8 +11930,8 @@
         </p:nvSpPr>
         <p:spPr>
           <a:xfrm>
-            <a:off x="8321040" y="2103120"/>
-            <a:ext cx="777240" cy="777240"/>
+            <a:off x="7978140" y="1965960"/>
+            <a:ext cx="731520" cy="731520"/>
           </a:xfrm>
           <a:prstGeom prst="ellipse">
             <a:avLst/>
@@ -11992,8 +11957,8 @@
         </p:nvSpPr>
         <p:spPr>
           <a:xfrm>
-            <a:off x="8321040" y="2103120"/>
-            <a:ext cx="777240" cy="777240"/>
+            <a:off x="7978140" y="1965960"/>
+            <a:ext cx="731520" cy="731520"/>
           </a:xfrm>
           <a:prstGeom prst="rect">
             <a:avLst/>
@@ -12031,8 +11996,8 @@
         </p:nvSpPr>
         <p:spPr>
           <a:xfrm>
-            <a:off x="7475220" y="2990088"/>
-            <a:ext cx="2468880" cy="320040"/>
+            <a:off x="7278624" y="2807208"/>
+            <a:ext cx="2130552" cy="320040"/>
           </a:xfrm>
           <a:prstGeom prst="rect">
             <a:avLst/>
@@ -12070,8 +12035,8 @@
         </p:nvSpPr>
         <p:spPr>
           <a:xfrm>
-            <a:off x="7475220" y="3300984"/>
-            <a:ext cx="2468880" cy="822960"/>
+            <a:off x="7278624" y="3118104"/>
+            <a:ext cx="2130552" cy="822960"/>
           </a:xfrm>
           <a:prstGeom prst="rect">
             <a:avLst/>
@@ -12112,8 +12077,8 @@
         </p:nvSpPr>
         <p:spPr>
           <a:xfrm>
-            <a:off x="9153144" y="2409444"/>
-            <a:ext cx="1719072" cy="164592"/>
+            <a:off x="8764524" y="2249424"/>
+            <a:ext cx="1399032" cy="164592"/>
           </a:xfrm>
           <a:prstGeom prst="rightArrow">
             <a:avLst/>
@@ -12132,8 +12097,8 @@
         </p:nvSpPr>
         <p:spPr>
           <a:xfrm>
-            <a:off x="10927080" y="2103120"/>
-            <a:ext cx="777240" cy="777240"/>
+            <a:off x="10218420" y="1965960"/>
+            <a:ext cx="731520" cy="731520"/>
           </a:xfrm>
           <a:prstGeom prst="ellipse">
             <a:avLst/>
@@ -12159,8 +12124,8 @@
         </p:nvSpPr>
         <p:spPr>
           <a:xfrm>
-            <a:off x="10927080" y="2103120"/>
-            <a:ext cx="777240" cy="777240"/>
+            <a:off x="10218420" y="1965960"/>
+            <a:ext cx="731520" cy="731520"/>
           </a:xfrm>
           <a:prstGeom prst="rect">
             <a:avLst/>
@@ -12198,8 +12163,8 @@
         </p:nvSpPr>
         <p:spPr>
           <a:xfrm>
-            <a:off x="10081260" y="2990088"/>
-            <a:ext cx="2468880" cy="320040"/>
+            <a:off x="9518904" y="2807208"/>
+            <a:ext cx="2130552" cy="320040"/>
           </a:xfrm>
           <a:prstGeom prst="rect">
             <a:avLst/>
@@ -12237,8 +12202,8 @@
         </p:nvSpPr>
         <p:spPr>
           <a:xfrm>
-            <a:off x="10081260" y="3300984"/>
-            <a:ext cx="2468880" cy="822960"/>
+            <a:off x="9518904" y="3118104"/>
+            <a:ext cx="2130552" cy="822960"/>
           </a:xfrm>
           <a:prstGeom prst="rect">
             <a:avLst/>
@@ -12279,12 +12244,12 @@
         </p:nvSpPr>
         <p:spPr>
           <a:xfrm>
-            <a:off x="502920" y="5074920"/>
-            <a:ext cx="5440680" cy="1005840"/>
+            <a:off x="502920" y="5349240"/>
+            <a:ext cx="5440680" cy="1051560"/>
           </a:xfrm>
           <a:prstGeom prst="roundRect">
             <a:avLst>
-              <a:gd name="adj" fmla="val 7273"/>
+              <a:gd name="adj" fmla="val 6957"/>
             </a:avLst>
           </a:prstGeom>
           <a:solidFill>
@@ -12301,8 +12266,8 @@
         </p:nvSpPr>
         <p:spPr>
           <a:xfrm>
-            <a:off x="502920" y="5184648"/>
-            <a:ext cx="5440680" cy="583387"/>
+            <a:off x="502920" y="5440680"/>
+            <a:ext cx="5440680" cy="483718"/>
           </a:xfrm>
           <a:prstGeom prst="rect">
             <a:avLst/>
@@ -12318,7 +12283,7 @@
               <a:buNone/>
             </a:pPr>
             <a:r>
-              <a:rPr lang="en-US" sz="3000" b="1" dirty="0">
+              <a:rPr lang="en-US" sz="2800" b="1" dirty="0">
                 <a:solidFill>
                   <a:srgbClr val="17A2B8"/>
                 </a:solidFill>
@@ -12328,7 +12293,7 @@
               </a:rPr>
               <a:t>3-5 min</a:t>
             </a:r>
-            <a:endParaRPr lang="en-US" sz="3000" dirty="0"/>
+            <a:endParaRPr lang="en-US" sz="2800" dirty="0"/>
           </a:p>
         </p:txBody>
       </p:sp>
@@ -12340,8 +12305,8 @@
         </p:nvSpPr>
         <p:spPr>
           <a:xfrm>
-            <a:off x="640080" y="5678424"/>
-            <a:ext cx="5166360" cy="382219"/>
+            <a:off x="640080" y="5896051"/>
+            <a:ext cx="5166360" cy="462686"/>
           </a:xfrm>
           <a:prstGeom prst="rect">
             <a:avLst/>
@@ -12382,106 +12347,45 @@
         </p:nvSpPr>
         <p:spPr>
           <a:xfrm>
-            <a:off x="6172200" y="5074920"/>
-            <a:ext cx="5440680" cy="1005840"/>
+            <a:off x="6172200" y="5349240"/>
+            <a:ext cx="5440680" cy="1051560"/>
           </a:xfrm>
           <a:prstGeom prst="roundRect">
             <a:avLst>
-              <a:gd name="adj" fmla="val 7273"/>
+              <a:gd name="adj" fmla="val 6957"/>
             </a:avLst>
           </a:prstGeom>
           <a:solidFill>
             <a:srgbClr val="EDF1F3"/>
           </a:solidFill>
           <a:ln/>
-          <a:effectLst>
-            <a:outerShdw sx="100000" sy="100000" kx="0" ky="0" algn="bl" rotWithShape="0" blurRad="63500" dist="25400" dir="5400000">
-              <a:srgbClr val="1A2530">
-                <a:alpha val="12000"/>
-              </a:srgbClr>
-            </a:outerShdw>
-          </a:effectLst>
-        </p:spPr>
-      </p:sp>
-      <p:sp>
-        <p:nvSpPr>
-          <p:cNvPr id="34" name="Shape 31"/>
-          <p:cNvSpPr/>
-          <p:nvPr/>
-        </p:nvSpPr>
-        <p:spPr>
-          <a:xfrm>
-            <a:off x="6355080" y="5257800"/>
-            <a:ext cx="457200" cy="457200"/>
-          </a:xfrm>
-          <a:prstGeom prst="ellipse">
-            <a:avLst/>
-          </a:prstGeom>
-          <a:solidFill>
-            <a:srgbClr val="5D6D7E"/>
-          </a:solidFill>
-          <a:ln/>
-          <a:effectLst>
-            <a:outerShdw sx="100000" sy="100000" kx="0" ky="0" algn="bl" rotWithShape="0" blurRad="76200" dist="25400" dir="5400000">
-              <a:srgbClr val="1A2530">
-                <a:alpha val="25000"/>
-              </a:srgbClr>
-            </a:outerShdw>
-          </a:effectLst>
-        </p:spPr>
-      </p:sp>
-      <p:pic>
-        <p:nvPicPr>
-          <p:cNvPr id="35" name="Image 1" descr="preencoded.png">    </p:cNvPr>
-          <p:cNvPicPr>
-            <a:picLocks noChangeAspect="1"/>
-          </p:cNvPicPr>
-          <p:nvPr/>
-        </p:nvPicPr>
-        <p:blipFill>
-          <a:blip r:embed="rId2"/>
-          <a:stretch>
-            <a:fillRect/>
-          </a:stretch>
-        </p:blipFill>
-        <p:spPr>
-          <a:xfrm>
-            <a:off x="6483096" y="5385816"/>
-            <a:ext cx="201168" cy="201168"/>
-          </a:xfrm>
-          <a:prstGeom prst="rect">
-            <a:avLst/>
-          </a:prstGeom>
-        </p:spPr>
-      </p:pic>
-      <p:sp>
-        <p:nvSpPr>
-          <p:cNvPr id="36" name="Text 32"/>
-          <p:cNvSpPr txBox="1"/>
-          <p:nvPr/>
-        </p:nvSpPr>
-        <p:spPr>
-          <a:xfrm>
-            <a:off x="6400800" y="5276088"/>
-            <a:ext cx="4983480" cy="667512"/>
-          </a:xfrm>
-          <a:prstGeom prst="rect">
-            <a:avLst/>
-          </a:prstGeom>
-          <a:noFill/>
-          <a:ln/>
-        </p:spPr>
-        <p:txBody>
-          <a:bodyPr wrap="square" lIns="0" tIns="0" rIns="0" bIns="0" rtlCol="0" anchor="t"/>
+        </p:spPr>
+      </p:sp>
+      <p:sp>
+        <p:nvSpPr>
+          <p:cNvPr id="34" name="Text 31"/>
+          <p:cNvSpPr txBox="1"/>
+          <p:nvPr/>
+        </p:nvSpPr>
+        <p:spPr>
+          <a:xfrm>
+            <a:off x="6382512" y="5468112"/>
+            <a:ext cx="5029200" cy="822960"/>
+          </a:xfrm>
+          <a:prstGeom prst="rect">
+            <a:avLst/>
+          </a:prstGeom>
+          <a:noFill/>
+          <a:ln/>
+        </p:spPr>
+        <p:txBody>
+          <a:bodyPr wrap="square" lIns="0" tIns="0" rIns="0" bIns="0" rtlCol="0" anchor="ctr"/>
           <a:lstStyle/>
           <a:p>
             <a:pPr indent="0" marL="0">
               <a:lnSpc>
-                <a:spcPts val="1472"/>
+                <a:spcPts val="1450"/>
               </a:lnSpc>
-              <a:spcAft>
-                <a:spcPts val="600"/>
-              </a:spcAft>
               <a:buNone/>
             </a:pPr>
             <a:r>
@@ -12501,7 +12405,7 @@
       </p:sp>
       <p:sp>
         <p:nvSpPr>
-          <p:cNvPr id="38" name="Text 33"/>
+          <p:cNvPr id="36" name="Text 32"/>
           <p:cNvSpPr txBox="1"/>
           <p:nvPr/>
         </p:nvSpPr>
@@ -12540,7 +12444,7 @@
       </p:sp>
       <p:sp>
         <p:nvSpPr>
-          <p:cNvPr id="39" name="Text 34"/>
+          <p:cNvPr id="37" name="Text 33"/>
           <p:cNvSpPr txBox="1"/>
           <p:nvPr/>
         </p:nvSpPr>
@@ -12707,8 +12611,8 @@
         </p:nvSpPr>
         <p:spPr>
           <a:xfrm>
-            <a:off x="1252728" y="603504"/>
-            <a:ext cx="9966960" cy="548640"/>
+            <a:off x="1252728" y="621792"/>
+            <a:ext cx="10195560" cy="548640"/>
           </a:xfrm>
           <a:prstGeom prst="rect">
             <a:avLst/>
@@ -12724,7 +12628,7 @@
               <a:buNone/>
             </a:pPr>
             <a:r>
-              <a:rPr lang="en-US" sz="2700" b="1" dirty="0">
+              <a:rPr lang="en-US" sz="2500" b="1" dirty="0">
                 <a:solidFill>
                   <a:srgbClr val="2C3E50"/>
                 </a:solidFill>
@@ -12732,9 +12636,9 @@
                 <a:ea typeface="Cambria" pitchFamily="34" charset="-122"/>
                 <a:cs typeface="Cambria" pitchFamily="34" charset="-120"/>
               </a:rPr>
-              <a:t>Posicionamiento: posición de olfateo ("sniffing position")</a:t>
-            </a:r>
-            <a:endParaRPr lang="en-US" sz="2700" dirty="0"/>
+              <a:t>Posicionamiento: posición de olfateo</a:t>
+            </a:r>
+            <a:endParaRPr lang="en-US" sz="2500" dirty="0"/>
           </a:p>
         </p:txBody>
       </p:sp>
@@ -12865,8 +12769,8 @@
         </p:nvSpPr>
         <p:spPr>
           <a:xfrm>
-            <a:off x="1289304" y="2130552"/>
-            <a:ext cx="4517136" cy="3813048"/>
+            <a:off x="1289304" y="2112264"/>
+            <a:ext cx="4517136" cy="3831336"/>
           </a:xfrm>
           <a:prstGeom prst="rect">
             <a:avLst/>
@@ -13102,8 +13006,8 @@
         </p:nvSpPr>
         <p:spPr>
           <a:xfrm>
-            <a:off x="6958584" y="2130552"/>
-            <a:ext cx="4471416" cy="3813048"/>
+            <a:off x="6958584" y="2112264"/>
+            <a:ext cx="4471416" cy="3831336"/>
           </a:xfrm>
           <a:prstGeom prst="rect">
             <a:avLst/>
@@ -13420,8 +13324,8 @@
         </p:nvSpPr>
         <p:spPr>
           <a:xfrm>
-            <a:off x="1252728" y="603504"/>
-            <a:ext cx="9966960" cy="548640"/>
+            <a:off x="1252728" y="621792"/>
+            <a:ext cx="10195560" cy="548640"/>
           </a:xfrm>
           <a:prstGeom prst="rect">
             <a:avLst/>
@@ -13437,7 +13341,7 @@
               <a:buNone/>
             </a:pPr>
             <a:r>
-              <a:rPr lang="en-US" sz="2700" b="1" dirty="0">
+              <a:rPr lang="en-US" sz="2500" b="1" dirty="0">
                 <a:solidFill>
                   <a:srgbClr val="2C3E50"/>
                 </a:solidFill>
@@ -13447,7 +13351,7 @@
               </a:rPr>
               <a:t>Laringoscopia directa: técnica paso a paso</a:t>
             </a:r>
-            <a:endParaRPr lang="en-US" sz="2700" dirty="0"/>
+            <a:endParaRPr lang="en-US" sz="2500" dirty="0"/>
           </a:p>
         </p:txBody>
       </p:sp>
@@ -13459,8 +13363,8 @@
         </p:nvSpPr>
         <p:spPr>
           <a:xfrm>
-            <a:off x="502920" y="1965960"/>
-            <a:ext cx="731520" cy="731520"/>
+            <a:off x="1107186" y="1965960"/>
+            <a:ext cx="658368" cy="658368"/>
           </a:xfrm>
           <a:prstGeom prst="ellipse">
             <a:avLst/>
@@ -13486,8 +13390,8 @@
         </p:nvSpPr>
         <p:spPr>
           <a:xfrm>
-            <a:off x="502920" y="1965960"/>
-            <a:ext cx="731520" cy="731520"/>
+            <a:off x="1107186" y="1965960"/>
+            <a:ext cx="658368" cy="658368"/>
           </a:xfrm>
           <a:prstGeom prst="rect">
             <a:avLst/>
@@ -13525,8 +13429,8 @@
         </p:nvSpPr>
         <p:spPr>
           <a:xfrm>
-            <a:off x="-132588" y="2807208"/>
-            <a:ext cx="2002536" cy="320040"/>
+            <a:off x="557784" y="2734056"/>
+            <a:ext cx="1757172" cy="320040"/>
           </a:xfrm>
           <a:prstGeom prst="rect">
             <a:avLst/>
@@ -13564,8 +13468,8 @@
         </p:nvSpPr>
         <p:spPr>
           <a:xfrm>
-            <a:off x="-132588" y="3118104"/>
-            <a:ext cx="2002536" cy="822960"/>
+            <a:off x="557784" y="3044952"/>
+            <a:ext cx="1757172" cy="822960"/>
           </a:xfrm>
           <a:prstGeom prst="rect">
             <a:avLst/>
@@ -13606,8 +13510,8 @@
         </p:nvSpPr>
         <p:spPr>
           <a:xfrm>
-            <a:off x="1271016" y="2249424"/>
-            <a:ext cx="1289304" cy="164592"/>
+            <a:off x="1820418" y="2212848"/>
+            <a:ext cx="1098804" cy="164592"/>
           </a:xfrm>
           <a:prstGeom prst="rightArrow">
             <a:avLst/>
@@ -13626,8 +13530,8 @@
         </p:nvSpPr>
         <p:spPr>
           <a:xfrm>
-            <a:off x="2596896" y="1965960"/>
-            <a:ext cx="731520" cy="731520"/>
+            <a:off x="2974086" y="1965960"/>
+            <a:ext cx="658368" cy="658368"/>
           </a:xfrm>
           <a:prstGeom prst="ellipse">
             <a:avLst/>
@@ -13653,8 +13557,8 @@
         </p:nvSpPr>
         <p:spPr>
           <a:xfrm>
-            <a:off x="2596896" y="1965960"/>
-            <a:ext cx="731520" cy="731520"/>
+            <a:off x="2974086" y="1965960"/>
+            <a:ext cx="658368" cy="658368"/>
           </a:xfrm>
           <a:prstGeom prst="rect">
             <a:avLst/>
@@ -13692,8 +13596,8 @@
         </p:nvSpPr>
         <p:spPr>
           <a:xfrm>
-            <a:off x="1961388" y="2807208"/>
-            <a:ext cx="2002536" cy="320040"/>
+            <a:off x="2424684" y="2734056"/>
+            <a:ext cx="1757172" cy="320040"/>
           </a:xfrm>
           <a:prstGeom prst="rect">
             <a:avLst/>
@@ -13731,8 +13635,8 @@
         </p:nvSpPr>
         <p:spPr>
           <a:xfrm>
-            <a:off x="1961388" y="3118104"/>
-            <a:ext cx="2002536" cy="822960"/>
+            <a:off x="2424684" y="3044952"/>
+            <a:ext cx="1757172" cy="822960"/>
           </a:xfrm>
           <a:prstGeom prst="rect">
             <a:avLst/>
@@ -13773,8 +13677,8 @@
         </p:nvSpPr>
         <p:spPr>
           <a:xfrm>
-            <a:off x="3364992" y="2249424"/>
-            <a:ext cx="1289304" cy="164592"/>
+            <a:off x="3687318" y="2212848"/>
+            <a:ext cx="1098804" cy="164592"/>
           </a:xfrm>
           <a:prstGeom prst="rightArrow">
             <a:avLst/>
@@ -13793,8 +13697,8 @@
         </p:nvSpPr>
         <p:spPr>
           <a:xfrm>
-            <a:off x="4690872" y="1965960"/>
-            <a:ext cx="731520" cy="731520"/>
+            <a:off x="4840986" y="1965960"/>
+            <a:ext cx="658368" cy="658368"/>
           </a:xfrm>
           <a:prstGeom prst="ellipse">
             <a:avLst/>
@@ -13820,8 +13724,8 @@
         </p:nvSpPr>
         <p:spPr>
           <a:xfrm>
-            <a:off x="4690872" y="1965960"/>
-            <a:ext cx="731520" cy="731520"/>
+            <a:off x="4840986" y="1965960"/>
+            <a:ext cx="658368" cy="658368"/>
           </a:xfrm>
           <a:prstGeom prst="rect">
             <a:avLst/>
@@ -13859,8 +13763,8 @@
         </p:nvSpPr>
         <p:spPr>
           <a:xfrm>
-            <a:off x="4055364" y="2807208"/>
-            <a:ext cx="2002536" cy="320040"/>
+            <a:off x="4291584" y="2734056"/>
+            <a:ext cx="1757172" cy="320040"/>
           </a:xfrm>
           <a:prstGeom prst="rect">
             <a:avLst/>
@@ -13898,8 +13802,8 @@
         </p:nvSpPr>
         <p:spPr>
           <a:xfrm>
-            <a:off x="4055364" y="3118104"/>
-            <a:ext cx="2002536" cy="822960"/>
+            <a:off x="4291584" y="3044952"/>
+            <a:ext cx="1757172" cy="822960"/>
           </a:xfrm>
           <a:prstGeom prst="rect">
             <a:avLst/>
@@ -13940,8 +13844,8 @@
         </p:nvSpPr>
         <p:spPr>
           <a:xfrm>
-            <a:off x="5458968" y="2249424"/>
-            <a:ext cx="1289304" cy="164592"/>
+            <a:off x="5554218" y="2212848"/>
+            <a:ext cx="1098804" cy="164592"/>
           </a:xfrm>
           <a:prstGeom prst="rightArrow">
             <a:avLst/>
@@ -13960,8 +13864,8 @@
         </p:nvSpPr>
         <p:spPr>
           <a:xfrm>
-            <a:off x="6784848" y="1965960"/>
-            <a:ext cx="731520" cy="731520"/>
+            <a:off x="6707886" y="1965960"/>
+            <a:ext cx="658368" cy="658368"/>
           </a:xfrm>
           <a:prstGeom prst="ellipse">
             <a:avLst/>
@@ -13987,8 +13891,8 @@
         </p:nvSpPr>
         <p:spPr>
           <a:xfrm>
-            <a:off x="6784848" y="1965960"/>
-            <a:ext cx="731520" cy="731520"/>
+            <a:off x="6707886" y="1965960"/>
+            <a:ext cx="658368" cy="658368"/>
           </a:xfrm>
           <a:prstGeom prst="rect">
             <a:avLst/>
@@ -14026,8 +13930,8 @@
         </p:nvSpPr>
         <p:spPr>
           <a:xfrm>
-            <a:off x="6149340" y="2807208"/>
-            <a:ext cx="2002536" cy="320040"/>
+            <a:off x="6158484" y="2734056"/>
+            <a:ext cx="1757172" cy="320040"/>
           </a:xfrm>
           <a:prstGeom prst="rect">
             <a:avLst/>
@@ -14065,8 +13969,8 @@
         </p:nvSpPr>
         <p:spPr>
           <a:xfrm>
-            <a:off x="6149340" y="3118104"/>
-            <a:ext cx="2002536" cy="822960"/>
+            <a:off x="6158484" y="3044952"/>
+            <a:ext cx="1757172" cy="822960"/>
           </a:xfrm>
           <a:prstGeom prst="rect">
             <a:avLst/>
@@ -14107,8 +14011,8 @@
         </p:nvSpPr>
         <p:spPr>
           <a:xfrm>
-            <a:off x="7552944" y="2249424"/>
-            <a:ext cx="1289304" cy="164592"/>
+            <a:off x="7421118" y="2212848"/>
+            <a:ext cx="1098804" cy="164592"/>
           </a:xfrm>
           <a:prstGeom prst="rightArrow">
             <a:avLst/>
@@ -14127,8 +14031,8 @@
         </p:nvSpPr>
         <p:spPr>
           <a:xfrm>
-            <a:off x="8878824" y="1965960"/>
-            <a:ext cx="731520" cy="731520"/>
+            <a:off x="8574786" y="1965960"/>
+            <a:ext cx="658368" cy="658368"/>
           </a:xfrm>
           <a:prstGeom prst="ellipse">
             <a:avLst/>
@@ -14154,8 +14058,8 @@
         </p:nvSpPr>
         <p:spPr>
           <a:xfrm>
-            <a:off x="8878824" y="1965960"/>
-            <a:ext cx="731520" cy="731520"/>
+            <a:off x="8574786" y="1965960"/>
+            <a:ext cx="658368" cy="658368"/>
           </a:xfrm>
           <a:prstGeom prst="rect">
             <a:avLst/>
@@ -14193,8 +14097,8 @@
         </p:nvSpPr>
         <p:spPr>
           <a:xfrm>
-            <a:off x="8243316" y="2807208"/>
-            <a:ext cx="2002536" cy="320040"/>
+            <a:off x="8025384" y="2734056"/>
+            <a:ext cx="1757172" cy="320040"/>
           </a:xfrm>
           <a:prstGeom prst="rect">
             <a:avLst/>
@@ -14232,8 +14136,8 @@
         </p:nvSpPr>
         <p:spPr>
           <a:xfrm>
-            <a:off x="8243316" y="3118104"/>
-            <a:ext cx="2002536" cy="822960"/>
+            <a:off x="8025384" y="3044952"/>
+            <a:ext cx="1757172" cy="822960"/>
           </a:xfrm>
           <a:prstGeom prst="rect">
             <a:avLst/>
@@ -14274,8 +14178,8 @@
         </p:nvSpPr>
         <p:spPr>
           <a:xfrm>
-            <a:off x="9646920" y="2249424"/>
-            <a:ext cx="1289304" cy="164592"/>
+            <a:off x="9288018" y="2212848"/>
+            <a:ext cx="1098804" cy="164592"/>
           </a:xfrm>
           <a:prstGeom prst="rightArrow">
             <a:avLst/>
@@ -14294,8 +14198,8 @@
         </p:nvSpPr>
         <p:spPr>
           <a:xfrm>
-            <a:off x="10972800" y="1965960"/>
-            <a:ext cx="731520" cy="731520"/>
+            <a:off x="10441686" y="1965960"/>
+            <a:ext cx="658368" cy="658368"/>
           </a:xfrm>
           <a:prstGeom prst="ellipse">
             <a:avLst/>
@@ -14321,8 +14225,8 @@
         </p:nvSpPr>
         <p:spPr>
           <a:xfrm>
-            <a:off x="10972800" y="1965960"/>
-            <a:ext cx="731520" cy="731520"/>
+            <a:off x="10441686" y="1965960"/>
+            <a:ext cx="658368" cy="658368"/>
           </a:xfrm>
           <a:prstGeom prst="rect">
             <a:avLst/>
@@ -14360,8 +14264,8 @@
         </p:nvSpPr>
         <p:spPr>
           <a:xfrm>
-            <a:off x="10337292" y="2807208"/>
-            <a:ext cx="2002536" cy="320040"/>
+            <a:off x="9892284" y="2734056"/>
+            <a:ext cx="1757172" cy="320040"/>
           </a:xfrm>
           <a:prstGeom prst="rect">
             <a:avLst/>
@@ -14399,8 +14303,8 @@
         </p:nvSpPr>
         <p:spPr>
           <a:xfrm>
-            <a:off x="10337292" y="3118104"/>
-            <a:ext cx="2002536" cy="822960"/>
+            <a:off x="9892284" y="3044952"/>
+            <a:ext cx="1757172" cy="822960"/>
           </a:xfrm>
           <a:prstGeom prst="rect">
             <a:avLst/>
@@ -14722,8 +14626,8 @@
         </p:nvSpPr>
         <p:spPr>
           <a:xfrm>
-            <a:off x="1252728" y="603504"/>
-            <a:ext cx="9966960" cy="548640"/>
+            <a:off x="1252728" y="621792"/>
+            <a:ext cx="10195560" cy="548640"/>
           </a:xfrm>
           <a:prstGeom prst="rect">
             <a:avLst/>
@@ -14739,7 +14643,7 @@
               <a:buNone/>
             </a:pPr>
             <a:r>
-              <a:rPr lang="en-US" sz="2700" b="1" dirty="0">
+              <a:rPr lang="en-US" sz="2500" b="1" dirty="0">
                 <a:solidFill>
                   <a:srgbClr val="2C3E50"/>
                 </a:solidFill>
@@ -14747,9 +14651,9 @@
                 <a:ea typeface="Cambria" pitchFamily="34" charset="-122"/>
                 <a:cs typeface="Cambria" pitchFamily="34" charset="-120"/>
               </a:rPr>
-              <a:t>Confirmación de la correcta colocación del tubo</a:t>
-            </a:r>
-            <a:endParaRPr lang="en-US" sz="2700" dirty="0"/>
+              <a:t>Confirmación de la colocación del tubo</a:t>
+            </a:r>
+            <a:endParaRPr lang="en-US" sz="2500" dirty="0"/>
           </a:p>
         </p:txBody>
       </p:sp>
@@ -14880,8 +14784,8 @@
         </p:nvSpPr>
         <p:spPr>
           <a:xfrm>
-            <a:off x="1289304" y="2130552"/>
-            <a:ext cx="2624328" cy="1207008"/>
+            <a:off x="1289304" y="2112264"/>
+            <a:ext cx="2624328" cy="1225296"/>
           </a:xfrm>
           <a:prstGeom prst="rect">
             <a:avLst/>
@@ -15044,8 +14948,8 @@
         </p:nvSpPr>
         <p:spPr>
           <a:xfrm>
-            <a:off x="5020056" y="2130552"/>
-            <a:ext cx="2624328" cy="1207008"/>
+            <a:off x="5020056" y="2112264"/>
+            <a:ext cx="2624328" cy="1225296"/>
           </a:xfrm>
           <a:prstGeom prst="rect">
             <a:avLst/>
@@ -15208,8 +15112,8 @@
         </p:nvSpPr>
         <p:spPr>
           <a:xfrm>
-            <a:off x="8750808" y="2130552"/>
-            <a:ext cx="2624328" cy="1207008"/>
+            <a:off x="8750808" y="2112264"/>
+            <a:ext cx="2624328" cy="1225296"/>
           </a:xfrm>
           <a:prstGeom prst="rect">
             <a:avLst/>
@@ -15372,8 +15276,8 @@
         </p:nvSpPr>
         <p:spPr>
           <a:xfrm>
-            <a:off x="1289304" y="4279392"/>
-            <a:ext cx="2624328" cy="1207008"/>
+            <a:off x="1289304" y="4261104"/>
+            <a:ext cx="2624328" cy="1225296"/>
           </a:xfrm>
           <a:prstGeom prst="rect">
             <a:avLst/>
@@ -15536,8 +15440,8 @@
         </p:nvSpPr>
         <p:spPr>
           <a:xfrm>
-            <a:off x="5020056" y="4279392"/>
-            <a:ext cx="2624328" cy="1207008"/>
+            <a:off x="5020056" y="4261104"/>
+            <a:ext cx="2624328" cy="1225296"/>
           </a:xfrm>
           <a:prstGeom prst="rect">
             <a:avLst/>
@@ -15700,8 +15604,8 @@
         </p:nvSpPr>
         <p:spPr>
           <a:xfrm>
-            <a:off x="8750808" y="4279392"/>
-            <a:ext cx="2624328" cy="1207008"/>
+            <a:off x="8750808" y="4261104"/>
+            <a:ext cx="2624328" cy="1225296"/>
           </a:xfrm>
           <a:prstGeom prst="rect">
             <a:avLst/>
@@ -15945,8 +15849,8 @@
         </p:nvSpPr>
         <p:spPr>
           <a:xfrm>
-            <a:off x="1252728" y="603504"/>
-            <a:ext cx="9966960" cy="548640"/>
+            <a:off x="1252728" y="621792"/>
+            <a:ext cx="10195560" cy="548640"/>
           </a:xfrm>
           <a:prstGeom prst="rect">
             <a:avLst/>
@@ -15962,7 +15866,7 @@
               <a:buNone/>
             </a:pPr>
             <a:r>
-              <a:rPr lang="en-US" sz="2700" b="1" dirty="0">
+              <a:rPr lang="en-US" sz="2500" b="1" dirty="0">
                 <a:solidFill>
                   <a:srgbClr val="2C3E50"/>
                 </a:solidFill>
@@ -15970,9 +15874,9 @@
                 <a:ea typeface="Cambria" pitchFamily="34" charset="-122"/>
                 <a:cs typeface="Cambria" pitchFamily="34" charset="-120"/>
               </a:rPr>
-              <a:t>Videolaringoscopia: ventajas y técnica moderna</a:t>
-            </a:r>
-            <a:endParaRPr lang="en-US" sz="2700" dirty="0"/>
+              <a:t>Videolaringoscopia: ventajas y técnica</a:t>
+            </a:r>
+            <a:endParaRPr lang="en-US" sz="2500" dirty="0"/>
           </a:p>
         </p:txBody>
       </p:sp>
@@ -16103,8 +16007,8 @@
         </p:nvSpPr>
         <p:spPr>
           <a:xfrm>
-            <a:off x="1289304" y="2130552"/>
-            <a:ext cx="4517136" cy="3813048"/>
+            <a:off x="1289304" y="2112264"/>
+            <a:ext cx="4517136" cy="3831336"/>
           </a:xfrm>
           <a:prstGeom prst="rect">
             <a:avLst/>
@@ -16364,8 +16268,8 @@
         </p:nvSpPr>
         <p:spPr>
           <a:xfrm>
-            <a:off x="6958584" y="2130552"/>
-            <a:ext cx="4471416" cy="3813048"/>
+            <a:off x="6958584" y="2112264"/>
+            <a:ext cx="4471416" cy="3831336"/>
           </a:xfrm>
           <a:prstGeom prst="rect">
             <a:avLst/>
@@ -16706,8 +16610,8 @@
         </p:nvSpPr>
         <p:spPr>
           <a:xfrm>
-            <a:off x="1252728" y="603504"/>
-            <a:ext cx="9966960" cy="548640"/>
+            <a:off x="1252728" y="621792"/>
+            <a:ext cx="10195560" cy="548640"/>
           </a:xfrm>
           <a:prstGeom prst="rect">
             <a:avLst/>
@@ -16723,7 +16627,7 @@
               <a:buNone/>
             </a:pPr>
             <a:r>
-              <a:rPr lang="en-US" sz="2700" b="1" dirty="0">
+              <a:rPr lang="en-US" sz="2500" b="1" dirty="0">
                 <a:solidFill>
                   <a:srgbClr val="2C3E50"/>
                 </a:solidFill>
@@ -16733,7 +16637,7 @@
               </a:rPr>
               <a:t>Contenido del capítulo</a:t>
             </a:r>
-            <a:endParaRPr lang="en-US" sz="2700" dirty="0"/>
+            <a:endParaRPr lang="en-US" sz="2500" dirty="0"/>
           </a:p>
         </p:txBody>
       </p:sp>
@@ -18168,8 +18072,8 @@
         </p:nvSpPr>
         <p:spPr>
           <a:xfrm>
-            <a:off x="1252728" y="603504"/>
-            <a:ext cx="9966960" cy="548640"/>
+            <a:off x="1252728" y="621792"/>
+            <a:ext cx="10195560" cy="548640"/>
           </a:xfrm>
           <a:prstGeom prst="rect">
             <a:avLst/>
@@ -18185,7 +18089,7 @@
               <a:buNone/>
             </a:pPr>
             <a:r>
-              <a:rPr lang="en-US" sz="2700" b="1" dirty="0">
+              <a:rPr lang="en-US" sz="2500" b="1" dirty="0">
                 <a:solidFill>
                   <a:srgbClr val="2C3E50"/>
                 </a:solidFill>
@@ -18193,9 +18097,9 @@
                 <a:ea typeface="Cambria" pitchFamily="34" charset="-122"/>
                 <a:cs typeface="Cambria" pitchFamily="34" charset="-120"/>
               </a:rPr>
-              <a:t>Intubación con fibrobroncoscopio: paciente despierto</a:t>
-            </a:r>
-            <a:endParaRPr lang="en-US" sz="2700" dirty="0"/>
+              <a:t>Fibrobroncoscopio: paciente despierto</a:t>
+            </a:r>
+            <a:endParaRPr lang="en-US" sz="2500" dirty="0"/>
           </a:p>
         </p:txBody>
       </p:sp>
@@ -18326,8 +18230,8 @@
         </p:nvSpPr>
         <p:spPr>
           <a:xfrm>
-            <a:off x="1289304" y="2130552"/>
-            <a:ext cx="4425696" cy="3813048"/>
+            <a:off x="1289304" y="2112264"/>
+            <a:ext cx="4425696" cy="3831336"/>
           </a:xfrm>
           <a:prstGeom prst="rect">
             <a:avLst/>
@@ -18587,8 +18491,8 @@
         </p:nvSpPr>
         <p:spPr>
           <a:xfrm>
-            <a:off x="6867144" y="2130552"/>
-            <a:ext cx="4636008" cy="3813048"/>
+            <a:off x="6867144" y="2112264"/>
+            <a:ext cx="4636008" cy="3831336"/>
           </a:xfrm>
           <a:prstGeom prst="rect">
             <a:avLst/>
@@ -18929,8 +18833,8 @@
         </p:nvSpPr>
         <p:spPr>
           <a:xfrm>
-            <a:off x="1252728" y="603504"/>
-            <a:ext cx="9966960" cy="548640"/>
+            <a:off x="1252728" y="621792"/>
+            <a:ext cx="10195560" cy="548640"/>
           </a:xfrm>
           <a:prstGeom prst="rect">
             <a:avLst/>
@@ -18946,7 +18850,7 @@
               <a:buNone/>
             </a:pPr>
             <a:r>
-              <a:rPr lang="en-US" sz="2700" b="1" dirty="0">
+              <a:rPr lang="en-US" sz="2500" b="1" dirty="0">
                 <a:solidFill>
                   <a:srgbClr val="2C3E50"/>
                 </a:solidFill>
@@ -18956,7 +18860,7 @@
               </a:rPr>
               <a:t>Indicaciones de la intubación traqueal</a:t>
             </a:r>
-            <a:endParaRPr lang="en-US" sz="2700" dirty="0"/>
+            <a:endParaRPr lang="en-US" sz="2500" dirty="0"/>
           </a:p>
         </p:txBody>
       </p:sp>
@@ -19879,8 +19783,8 @@
         </p:nvSpPr>
         <p:spPr>
           <a:xfrm>
-            <a:off x="1252728" y="603504"/>
-            <a:ext cx="9966960" cy="548640"/>
+            <a:off x="1252728" y="621792"/>
+            <a:ext cx="10195560" cy="548640"/>
           </a:xfrm>
           <a:prstGeom prst="rect">
             <a:avLst/>
@@ -19896,7 +19800,7 @@
               <a:buNone/>
             </a:pPr>
             <a:r>
-              <a:rPr lang="en-US" sz="2700" b="1" dirty="0">
+              <a:rPr lang="en-US" sz="2500" b="1" dirty="0">
                 <a:solidFill>
                   <a:srgbClr val="2C3E50"/>
                 </a:solidFill>
@@ -19906,7 +19810,7 @@
               </a:rPr>
               <a:t>Reconocimiento y algoritmo de manejo</a:t>
             </a:r>
-            <a:endParaRPr lang="en-US" sz="2700" dirty="0"/>
+            <a:endParaRPr lang="en-US" sz="2500" dirty="0"/>
           </a:p>
         </p:txBody>
       </p:sp>
@@ -19918,12 +19822,12 @@
         </p:nvSpPr>
         <p:spPr>
           <a:xfrm>
-            <a:off x="4480560" y="1481328"/>
-            <a:ext cx="3200400" cy="502920"/>
+            <a:off x="4480560" y="1371600"/>
+            <a:ext cx="3200400" cy="457200"/>
           </a:xfrm>
           <a:prstGeom prst="roundRect">
             <a:avLst>
-              <a:gd name="adj" fmla="val 10909"/>
+              <a:gd name="adj" fmla="val 12000"/>
             </a:avLst>
           </a:prstGeom>
           <a:solidFill>
@@ -19940,8 +19844,8 @@
         </p:nvSpPr>
         <p:spPr>
           <a:xfrm>
-            <a:off x="4590288" y="1517904"/>
-            <a:ext cx="2980944" cy="429768"/>
+            <a:off x="4590288" y="1408176"/>
+            <a:ext cx="2980944" cy="384048"/>
           </a:xfrm>
           <a:prstGeom prst="rect">
             <a:avLst/>
@@ -19982,8 +19886,8 @@
         </p:nvSpPr>
         <p:spPr>
           <a:xfrm>
-            <a:off x="5998464" y="2011680"/>
-            <a:ext cx="164592" cy="201168"/>
+            <a:off x="5998464" y="1847088"/>
+            <a:ext cx="164592" cy="146304"/>
           </a:xfrm>
           <a:prstGeom prst="downArrow">
             <a:avLst/>
@@ -20002,12 +19906,12 @@
         </p:nvSpPr>
         <p:spPr>
           <a:xfrm>
-            <a:off x="4480560" y="2240280"/>
-            <a:ext cx="3200400" cy="502920"/>
+            <a:off x="4480560" y="2011680"/>
+            <a:ext cx="3200400" cy="457200"/>
           </a:xfrm>
           <a:prstGeom prst="roundRect">
             <a:avLst>
-              <a:gd name="adj" fmla="val 10909"/>
+              <a:gd name="adj" fmla="val 12000"/>
             </a:avLst>
           </a:prstGeom>
           <a:solidFill>
@@ -20024,8 +19928,8 @@
         </p:nvSpPr>
         <p:spPr>
           <a:xfrm>
-            <a:off x="4590288" y="2276856"/>
-            <a:ext cx="2980944" cy="429768"/>
+            <a:off x="4590288" y="2048256"/>
+            <a:ext cx="2980944" cy="384048"/>
           </a:xfrm>
           <a:prstGeom prst="rect">
             <a:avLst/>
@@ -20066,8 +19970,8 @@
         </p:nvSpPr>
         <p:spPr>
           <a:xfrm>
-            <a:off x="5998464" y="2770632"/>
-            <a:ext cx="164592" cy="201168"/>
+            <a:off x="5998464" y="2487168"/>
+            <a:ext cx="164592" cy="146304"/>
           </a:xfrm>
           <a:prstGeom prst="downArrow">
             <a:avLst/>
@@ -20086,12 +19990,12 @@
         </p:nvSpPr>
         <p:spPr>
           <a:xfrm>
-            <a:off x="4480560" y="2999232"/>
-            <a:ext cx="3200400" cy="457200"/>
+            <a:off x="4480560" y="2651760"/>
+            <a:ext cx="3200400" cy="420624"/>
           </a:xfrm>
           <a:prstGeom prst="roundRect">
             <a:avLst>
-              <a:gd name="adj" fmla="val 12000"/>
+              <a:gd name="adj" fmla="val 13043"/>
             </a:avLst>
           </a:prstGeom>
           <a:solidFill>
@@ -20108,8 +20012,8 @@
         </p:nvSpPr>
         <p:spPr>
           <a:xfrm>
-            <a:off x="4590288" y="3035808"/>
-            <a:ext cx="2980944" cy="384048"/>
+            <a:off x="4590288" y="2688336"/>
+            <a:ext cx="2980944" cy="347472"/>
           </a:xfrm>
           <a:prstGeom prst="rect">
             <a:avLst/>
@@ -20150,8 +20054,8 @@
         </p:nvSpPr>
         <p:spPr>
           <a:xfrm>
-            <a:off x="6080760" y="3456432"/>
-            <a:ext cx="0" cy="201168"/>
+            <a:off x="6080760" y="3072384"/>
+            <a:ext cx="0" cy="146304"/>
           </a:xfrm>
           <a:prstGeom prst="line">
             <a:avLst/>
@@ -20173,7 +20077,7 @@
         </p:nvSpPr>
         <p:spPr>
           <a:xfrm>
-            <a:off x="1920240" y="3657600"/>
+            <a:off x="1920240" y="3218688"/>
             <a:ext cx="8321040" cy="0"/>
           </a:xfrm>
           <a:prstGeom prst="line">
@@ -20196,8 +20100,8 @@
         </p:nvSpPr>
         <p:spPr>
           <a:xfrm>
-            <a:off x="1920240" y="3657600"/>
-            <a:ext cx="0" cy="137160"/>
+            <a:off x="1920240" y="3218688"/>
+            <a:ext cx="0" cy="118872"/>
           </a:xfrm>
           <a:prstGeom prst="line">
             <a:avLst/>
@@ -20219,8 +20123,8 @@
         </p:nvSpPr>
         <p:spPr>
           <a:xfrm>
-            <a:off x="6080760" y="3657600"/>
-            <a:ext cx="0" cy="137160"/>
+            <a:off x="6080760" y="3218688"/>
+            <a:ext cx="0" cy="118872"/>
           </a:xfrm>
           <a:prstGeom prst="line">
             <a:avLst/>
@@ -20242,8 +20146,8 @@
         </p:nvSpPr>
         <p:spPr>
           <a:xfrm>
-            <a:off x="10241280" y="3657600"/>
-            <a:ext cx="0" cy="137160"/>
+            <a:off x="10241280" y="3218688"/>
+            <a:ext cx="0" cy="118872"/>
           </a:xfrm>
           <a:prstGeom prst="line">
             <a:avLst/>
@@ -20265,8 +20169,8 @@
         </p:nvSpPr>
         <p:spPr>
           <a:xfrm>
-            <a:off x="822960" y="3246120"/>
-            <a:ext cx="1005840" cy="274320"/>
+            <a:off x="822960" y="3355848"/>
+            <a:ext cx="1005840" cy="219456"/>
           </a:xfrm>
           <a:prstGeom prst="rect">
             <a:avLst/>
@@ -20304,8 +20208,8 @@
         </p:nvSpPr>
         <p:spPr>
           <a:xfrm>
-            <a:off x="5212080" y="3246120"/>
-            <a:ext cx="1737360" cy="274320"/>
+            <a:off x="5212080" y="3355848"/>
+            <a:ext cx="1737360" cy="219456"/>
           </a:xfrm>
           <a:prstGeom prst="rect">
             <a:avLst/>
@@ -20343,8 +20247,8 @@
         </p:nvSpPr>
         <p:spPr>
           <a:xfrm>
-            <a:off x="9281160" y="3246120"/>
-            <a:ext cx="1920240" cy="274320"/>
+            <a:off x="9281160" y="3355848"/>
+            <a:ext cx="1920240" cy="219456"/>
           </a:xfrm>
           <a:prstGeom prst="rect">
             <a:avLst/>
@@ -20382,12 +20286,12 @@
         </p:nvSpPr>
         <p:spPr>
           <a:xfrm>
-            <a:off x="502920" y="3794760"/>
-            <a:ext cx="3749040" cy="777240"/>
+            <a:off x="502920" y="3602736"/>
+            <a:ext cx="3749040" cy="868680"/>
           </a:xfrm>
           <a:prstGeom prst="roundRect">
             <a:avLst>
-              <a:gd name="adj" fmla="val 7059"/>
+              <a:gd name="adj" fmla="val 6316"/>
             </a:avLst>
           </a:prstGeom>
           <a:solidFill>
@@ -20404,8 +20308,8 @@
         </p:nvSpPr>
         <p:spPr>
           <a:xfrm>
-            <a:off x="612648" y="3831336"/>
-            <a:ext cx="3529584" cy="704088"/>
+            <a:off x="612648" y="3639312"/>
+            <a:ext cx="3529584" cy="795528"/>
           </a:xfrm>
           <a:prstGeom prst="rect">
             <a:avLst/>
@@ -20446,7 +20350,7 @@
         </p:nvSpPr>
         <p:spPr>
           <a:xfrm>
-            <a:off x="4480560" y="3794760"/>
+            <a:off x="4480560" y="3602736"/>
             <a:ext cx="3200400" cy="868680"/>
           </a:xfrm>
           <a:prstGeom prst="roundRect">
@@ -20468,7 +20372,7 @@
         </p:nvSpPr>
         <p:spPr>
           <a:xfrm>
-            <a:off x="4590288" y="3831336"/>
+            <a:off x="4590288" y="3639312"/>
             <a:ext cx="2980944" cy="795528"/>
           </a:xfrm>
           <a:prstGeom prst="rect">
@@ -20510,7 +20414,7 @@
         </p:nvSpPr>
         <p:spPr>
           <a:xfrm>
-            <a:off x="8503920" y="3794760"/>
+            <a:off x="8503920" y="3602736"/>
             <a:ext cx="3154680" cy="868680"/>
           </a:xfrm>
           <a:prstGeom prst="roundRect">
@@ -20532,7 +20436,7 @@
         </p:nvSpPr>
         <p:spPr>
           <a:xfrm>
-            <a:off x="8613648" y="3831336"/>
+            <a:off x="8613648" y="3639312"/>
             <a:ext cx="2935224" cy="795528"/>
           </a:xfrm>
           <a:prstGeom prst="rect">
@@ -20574,8 +20478,8 @@
         </p:nvSpPr>
         <p:spPr>
           <a:xfrm>
-            <a:off x="5998464" y="4700016"/>
-            <a:ext cx="164592" cy="182880"/>
+            <a:off x="5998464" y="4507992"/>
+            <a:ext cx="164592" cy="146304"/>
           </a:xfrm>
           <a:prstGeom prst="downArrow">
             <a:avLst/>
@@ -20594,12 +20498,12 @@
         </p:nvSpPr>
         <p:spPr>
           <a:xfrm>
-            <a:off x="4480560" y="4919472"/>
-            <a:ext cx="3200400" cy="640080"/>
+            <a:off x="4480560" y="4690872"/>
+            <a:ext cx="3200400" cy="594360"/>
           </a:xfrm>
           <a:prstGeom prst="roundRect">
             <a:avLst>
-              <a:gd name="adj" fmla="val 8571"/>
+              <a:gd name="adj" fmla="val 9231"/>
             </a:avLst>
           </a:prstGeom>
           <a:solidFill>
@@ -20616,8 +20520,8 @@
         </p:nvSpPr>
         <p:spPr>
           <a:xfrm>
-            <a:off x="4590288" y="4956048"/>
-            <a:ext cx="2980944" cy="566928"/>
+            <a:off x="4590288" y="4727448"/>
+            <a:ext cx="2980944" cy="521208"/>
           </a:xfrm>
           <a:prstGeom prst="rect">
             <a:avLst/>
@@ -20658,8 +20562,8 @@
         </p:nvSpPr>
         <p:spPr>
           <a:xfrm>
-            <a:off x="9994392" y="4700016"/>
-            <a:ext cx="164592" cy="182880"/>
+            <a:off x="9994392" y="4507992"/>
+            <a:ext cx="164592" cy="146304"/>
           </a:xfrm>
           <a:prstGeom prst="downArrow">
             <a:avLst/>
@@ -20678,12 +20582,12 @@
         </p:nvSpPr>
         <p:spPr>
           <a:xfrm>
-            <a:off x="8503920" y="4919472"/>
-            <a:ext cx="3154680" cy="640080"/>
+            <a:off x="8503920" y="4690872"/>
+            <a:ext cx="3154680" cy="594360"/>
           </a:xfrm>
           <a:prstGeom prst="roundRect">
             <a:avLst>
-              <a:gd name="adj" fmla="val 8571"/>
+              <a:gd name="adj" fmla="val 9231"/>
             </a:avLst>
           </a:prstGeom>
           <a:solidFill>
@@ -20700,8 +20604,8 @@
         </p:nvSpPr>
         <p:spPr>
           <a:xfrm>
-            <a:off x="8613648" y="4956048"/>
-            <a:ext cx="2935224" cy="566928"/>
+            <a:off x="8613648" y="4727448"/>
+            <a:ext cx="2935224" cy="521208"/>
           </a:xfrm>
           <a:prstGeom prst="rect">
             <a:avLst/>
@@ -20742,12 +20646,12 @@
         </p:nvSpPr>
         <p:spPr>
           <a:xfrm>
-            <a:off x="502920" y="5779008"/>
-            <a:ext cx="11201400" cy="566928"/>
+            <a:off x="502920" y="5468112"/>
+            <a:ext cx="11201400" cy="548640"/>
           </a:xfrm>
           <a:prstGeom prst="roundRect">
             <a:avLst>
-              <a:gd name="adj" fmla="val 9677"/>
+              <a:gd name="adj" fmla="val 10000"/>
             </a:avLst>
           </a:prstGeom>
           <a:solidFill>
@@ -20764,8 +20668,8 @@
         </p:nvSpPr>
         <p:spPr>
           <a:xfrm>
-            <a:off x="777240" y="5852160"/>
-            <a:ext cx="10789920" cy="438912"/>
+            <a:off x="777240" y="5532120"/>
+            <a:ext cx="10789920" cy="420624"/>
           </a:xfrm>
           <a:prstGeom prst="rect">
             <a:avLst/>
@@ -21017,8 +20921,8 @@
         </p:nvSpPr>
         <p:spPr>
           <a:xfrm>
-            <a:off x="1252728" y="603504"/>
-            <a:ext cx="9966960" cy="548640"/>
+            <a:off x="1252728" y="621792"/>
+            <a:ext cx="10195560" cy="548640"/>
           </a:xfrm>
           <a:prstGeom prst="rect">
             <a:avLst/>
@@ -21034,7 +20938,7 @@
               <a:buNone/>
             </a:pPr>
             <a:r>
-              <a:rPr lang="en-US" sz="2700" b="1" dirty="0">
+              <a:rPr lang="en-US" sz="2500" b="1" dirty="0">
                 <a:solidFill>
                   <a:srgbClr val="2C3E50"/>
                 </a:solidFill>
@@ -21042,9 +20946,9 @@
                 <a:ea typeface="Cambria" pitchFamily="34" charset="-122"/>
                 <a:cs typeface="Cambria" pitchFamily="34" charset="-120"/>
               </a:rPr>
-              <a:t>Complicaciones inmediatas de la intubación traqueal</a:t>
-            </a:r>
-            <a:endParaRPr lang="en-US" sz="2700" dirty="0"/>
+              <a:t>Complicaciones inmediatas</a:t>
+            </a:r>
+            <a:endParaRPr lang="en-US" sz="2500" dirty="0"/>
           </a:p>
         </p:txBody>
       </p:sp>
@@ -21175,8 +21079,8 @@
         </p:nvSpPr>
         <p:spPr>
           <a:xfrm>
-            <a:off x="1289304" y="2130552"/>
-            <a:ext cx="2624328" cy="1207008"/>
+            <a:off x="1289304" y="2112264"/>
+            <a:ext cx="2624328" cy="1225296"/>
           </a:xfrm>
           <a:prstGeom prst="rect">
             <a:avLst/>
@@ -21339,8 +21243,8 @@
         </p:nvSpPr>
         <p:spPr>
           <a:xfrm>
-            <a:off x="5020056" y="2130552"/>
-            <a:ext cx="2624328" cy="1207008"/>
+            <a:off x="5020056" y="2386584"/>
+            <a:ext cx="2624328" cy="950976"/>
           </a:xfrm>
           <a:prstGeom prst="rect">
             <a:avLst/>
@@ -21503,8 +21407,8 @@
         </p:nvSpPr>
         <p:spPr>
           <a:xfrm>
-            <a:off x="8750808" y="2130552"/>
-            <a:ext cx="2624328" cy="1207008"/>
+            <a:off x="8750808" y="2112264"/>
+            <a:ext cx="2624328" cy="1225296"/>
           </a:xfrm>
           <a:prstGeom prst="rect">
             <a:avLst/>
@@ -21667,8 +21571,8 @@
         </p:nvSpPr>
         <p:spPr>
           <a:xfrm>
-            <a:off x="1289304" y="4279392"/>
-            <a:ext cx="2624328" cy="1207008"/>
+            <a:off x="1289304" y="4261104"/>
+            <a:ext cx="2624328" cy="1225296"/>
           </a:xfrm>
           <a:prstGeom prst="rect">
             <a:avLst/>
@@ -21831,8 +21735,8 @@
         </p:nvSpPr>
         <p:spPr>
           <a:xfrm>
-            <a:off x="5020056" y="4279392"/>
-            <a:ext cx="2624328" cy="1207008"/>
+            <a:off x="5020056" y="4261104"/>
+            <a:ext cx="2624328" cy="1225296"/>
           </a:xfrm>
           <a:prstGeom prst="rect">
             <a:avLst/>
@@ -21995,8 +21899,8 @@
         </p:nvSpPr>
         <p:spPr>
           <a:xfrm>
-            <a:off x="8750808" y="4279392"/>
-            <a:ext cx="2624328" cy="1207008"/>
+            <a:off x="8750808" y="4261104"/>
+            <a:ext cx="2624328" cy="1225296"/>
           </a:xfrm>
           <a:prstGeom prst="rect">
             <a:avLst/>
@@ -22240,8 +22144,8 @@
         </p:nvSpPr>
         <p:spPr>
           <a:xfrm>
-            <a:off x="1252728" y="603504"/>
-            <a:ext cx="9966960" cy="548640"/>
+            <a:off x="1252728" y="621792"/>
+            <a:ext cx="10195560" cy="548640"/>
           </a:xfrm>
           <a:prstGeom prst="rect">
             <a:avLst/>
@@ -22257,7 +22161,7 @@
               <a:buNone/>
             </a:pPr>
             <a:r>
-              <a:rPr lang="en-US" sz="2700" b="1" dirty="0">
+              <a:rPr lang="en-US" sz="2500" b="1" dirty="0">
                 <a:solidFill>
                   <a:srgbClr val="2C3E50"/>
                 </a:solidFill>
@@ -22265,9 +22169,9 @@
                 <a:ea typeface="Cambria" pitchFamily="34" charset="-122"/>
                 <a:cs typeface="Cambria" pitchFamily="34" charset="-120"/>
               </a:rPr>
-              <a:t>Complicaciones tardías de la intubación traqueal</a:t>
-            </a:r>
-            <a:endParaRPr lang="en-US" sz="2700" dirty="0"/>
+              <a:t>Complicaciones tardías</a:t>
+            </a:r>
+            <a:endParaRPr lang="en-US" sz="2500" dirty="0"/>
           </a:p>
         </p:txBody>
       </p:sp>
@@ -22398,8 +22302,8 @@
         </p:nvSpPr>
         <p:spPr>
           <a:xfrm>
-            <a:off x="1289304" y="2130552"/>
-            <a:ext cx="4425696" cy="3813048"/>
+            <a:off x="1289304" y="2112264"/>
+            <a:ext cx="4425696" cy="3831336"/>
           </a:xfrm>
           <a:prstGeom prst="rect">
             <a:avLst/>
@@ -22635,8 +22539,8 @@
         </p:nvSpPr>
         <p:spPr>
           <a:xfrm>
-            <a:off x="6867144" y="2130552"/>
-            <a:ext cx="4636008" cy="3813048"/>
+            <a:off x="6867144" y="2112264"/>
+            <a:ext cx="4636008" cy="3831336"/>
           </a:xfrm>
           <a:prstGeom prst="rect">
             <a:avLst/>
@@ -22953,8 +22857,8 @@
         </p:nvSpPr>
         <p:spPr>
           <a:xfrm>
-            <a:off x="1252728" y="603504"/>
-            <a:ext cx="9966960" cy="548640"/>
+            <a:off x="1252728" y="621792"/>
+            <a:ext cx="10195560" cy="548640"/>
           </a:xfrm>
           <a:prstGeom prst="rect">
             <a:avLst/>
@@ -22970,7 +22874,7 @@
               <a:buNone/>
             </a:pPr>
             <a:r>
-              <a:rPr lang="en-US" sz="2700" b="1" dirty="0">
+              <a:rPr lang="en-US" sz="2500" b="1" dirty="0">
                 <a:solidFill>
                   <a:srgbClr val="2C3E50"/>
                 </a:solidFill>
@@ -22980,7 +22884,7 @@
               </a:rPr>
               <a:t>Intubación de secuencia rápida (RSI)</a:t>
             </a:r>
-            <a:endParaRPr lang="en-US" sz="2700" dirty="0"/>
+            <a:endParaRPr lang="en-US" sz="2500" dirty="0"/>
           </a:p>
         </p:txBody>
       </p:sp>
@@ -23034,8 +22938,8 @@
         </p:nvSpPr>
         <p:spPr>
           <a:xfrm>
-            <a:off x="502920" y="2331720"/>
-            <a:ext cx="731520" cy="731520"/>
+            <a:off x="1107186" y="2286000"/>
+            <a:ext cx="658368" cy="658368"/>
           </a:xfrm>
           <a:prstGeom prst="ellipse">
             <a:avLst/>
@@ -23061,8 +22965,8 @@
         </p:nvSpPr>
         <p:spPr>
           <a:xfrm>
-            <a:off x="502920" y="2331720"/>
-            <a:ext cx="731520" cy="731520"/>
+            <a:off x="1107186" y="2286000"/>
+            <a:ext cx="658368" cy="658368"/>
           </a:xfrm>
           <a:prstGeom prst="rect">
             <a:avLst/>
@@ -23100,8 +23004,8 @@
         </p:nvSpPr>
         <p:spPr>
           <a:xfrm>
-            <a:off x="-132588" y="3172968"/>
-            <a:ext cx="2002536" cy="320040"/>
+            <a:off x="557784" y="3054096"/>
+            <a:ext cx="1757172" cy="320040"/>
           </a:xfrm>
           <a:prstGeom prst="rect">
             <a:avLst/>
@@ -23139,8 +23043,8 @@
         </p:nvSpPr>
         <p:spPr>
           <a:xfrm>
-            <a:off x="-132588" y="3483864"/>
-            <a:ext cx="2002536" cy="822960"/>
+            <a:off x="557784" y="3364992"/>
+            <a:ext cx="1757172" cy="822960"/>
           </a:xfrm>
           <a:prstGeom prst="rect">
             <a:avLst/>
@@ -23181,8 +23085,8 @@
         </p:nvSpPr>
         <p:spPr>
           <a:xfrm>
-            <a:off x="1271016" y="2615184"/>
-            <a:ext cx="1289304" cy="164592"/>
+            <a:off x="1820418" y="2532888"/>
+            <a:ext cx="1098804" cy="164592"/>
           </a:xfrm>
           <a:prstGeom prst="rightArrow">
             <a:avLst/>
@@ -23201,8 +23105,8 @@
         </p:nvSpPr>
         <p:spPr>
           <a:xfrm>
-            <a:off x="2596896" y="2331720"/>
-            <a:ext cx="731520" cy="731520"/>
+            <a:off x="2974086" y="2286000"/>
+            <a:ext cx="658368" cy="658368"/>
           </a:xfrm>
           <a:prstGeom prst="ellipse">
             <a:avLst/>
@@ -23228,8 +23132,8 @@
         </p:nvSpPr>
         <p:spPr>
           <a:xfrm>
-            <a:off x="2596896" y="2331720"/>
-            <a:ext cx="731520" cy="731520"/>
+            <a:off x="2974086" y="2286000"/>
+            <a:ext cx="658368" cy="658368"/>
           </a:xfrm>
           <a:prstGeom prst="rect">
             <a:avLst/>
@@ -23267,8 +23171,8 @@
         </p:nvSpPr>
         <p:spPr>
           <a:xfrm>
-            <a:off x="1961388" y="3172968"/>
-            <a:ext cx="2002536" cy="320040"/>
+            <a:off x="2424684" y="3054096"/>
+            <a:ext cx="1757172" cy="320040"/>
           </a:xfrm>
           <a:prstGeom prst="rect">
             <a:avLst/>
@@ -23306,8 +23210,8 @@
         </p:nvSpPr>
         <p:spPr>
           <a:xfrm>
-            <a:off x="1961388" y="3483864"/>
-            <a:ext cx="2002536" cy="822960"/>
+            <a:off x="2424684" y="3364992"/>
+            <a:ext cx="1757172" cy="822960"/>
           </a:xfrm>
           <a:prstGeom prst="rect">
             <a:avLst/>
@@ -23348,8 +23252,8 @@
         </p:nvSpPr>
         <p:spPr>
           <a:xfrm>
-            <a:off x="3364992" y="2615184"/>
-            <a:ext cx="1289304" cy="164592"/>
+            <a:off x="3687318" y="2532888"/>
+            <a:ext cx="1098804" cy="164592"/>
           </a:xfrm>
           <a:prstGeom prst="rightArrow">
             <a:avLst/>
@@ -23368,8 +23272,8 @@
         </p:nvSpPr>
         <p:spPr>
           <a:xfrm>
-            <a:off x="4690872" y="2331720"/>
-            <a:ext cx="731520" cy="731520"/>
+            <a:off x="4840986" y="2286000"/>
+            <a:ext cx="658368" cy="658368"/>
           </a:xfrm>
           <a:prstGeom prst="ellipse">
             <a:avLst/>
@@ -23395,8 +23299,8 @@
         </p:nvSpPr>
         <p:spPr>
           <a:xfrm>
-            <a:off x="4690872" y="2331720"/>
-            <a:ext cx="731520" cy="731520"/>
+            <a:off x="4840986" y="2286000"/>
+            <a:ext cx="658368" cy="658368"/>
           </a:xfrm>
           <a:prstGeom prst="rect">
             <a:avLst/>
@@ -23434,8 +23338,8 @@
         </p:nvSpPr>
         <p:spPr>
           <a:xfrm>
-            <a:off x="4055364" y="3172968"/>
-            <a:ext cx="2002536" cy="320040"/>
+            <a:off x="4291584" y="3054096"/>
+            <a:ext cx="1757172" cy="320040"/>
           </a:xfrm>
           <a:prstGeom prst="rect">
             <a:avLst/>
@@ -23473,8 +23377,8 @@
         </p:nvSpPr>
         <p:spPr>
           <a:xfrm>
-            <a:off x="4055364" y="3483864"/>
-            <a:ext cx="2002536" cy="822960"/>
+            <a:off x="4291584" y="3364992"/>
+            <a:ext cx="1757172" cy="822960"/>
           </a:xfrm>
           <a:prstGeom prst="rect">
             <a:avLst/>
@@ -23515,8 +23419,8 @@
         </p:nvSpPr>
         <p:spPr>
           <a:xfrm>
-            <a:off x="5458968" y="2615184"/>
-            <a:ext cx="1289304" cy="164592"/>
+            <a:off x="5554218" y="2532888"/>
+            <a:ext cx="1098804" cy="164592"/>
           </a:xfrm>
           <a:prstGeom prst="rightArrow">
             <a:avLst/>
@@ -23535,8 +23439,8 @@
         </p:nvSpPr>
         <p:spPr>
           <a:xfrm>
-            <a:off x="6784848" y="2331720"/>
-            <a:ext cx="731520" cy="731520"/>
+            <a:off x="6707886" y="2286000"/>
+            <a:ext cx="658368" cy="658368"/>
           </a:xfrm>
           <a:prstGeom prst="ellipse">
             <a:avLst/>
@@ -23562,8 +23466,8 @@
         </p:nvSpPr>
         <p:spPr>
           <a:xfrm>
-            <a:off x="6784848" y="2331720"/>
-            <a:ext cx="731520" cy="731520"/>
+            <a:off x="6707886" y="2286000"/>
+            <a:ext cx="658368" cy="658368"/>
           </a:xfrm>
           <a:prstGeom prst="rect">
             <a:avLst/>
@@ -23601,8 +23505,8 @@
         </p:nvSpPr>
         <p:spPr>
           <a:xfrm>
-            <a:off x="6149340" y="3172968"/>
-            <a:ext cx="2002536" cy="320040"/>
+            <a:off x="6158484" y="3054096"/>
+            <a:ext cx="1757172" cy="320040"/>
           </a:xfrm>
           <a:prstGeom prst="rect">
             <a:avLst/>
@@ -23640,8 +23544,8 @@
         </p:nvSpPr>
         <p:spPr>
           <a:xfrm>
-            <a:off x="6149340" y="3483864"/>
-            <a:ext cx="2002536" cy="822960"/>
+            <a:off x="6158484" y="3364992"/>
+            <a:ext cx="1757172" cy="822960"/>
           </a:xfrm>
           <a:prstGeom prst="rect">
             <a:avLst/>
@@ -23682,8 +23586,8 @@
         </p:nvSpPr>
         <p:spPr>
           <a:xfrm>
-            <a:off x="7552944" y="2615184"/>
-            <a:ext cx="1289304" cy="164592"/>
+            <a:off x="7421118" y="2532888"/>
+            <a:ext cx="1098804" cy="164592"/>
           </a:xfrm>
           <a:prstGeom prst="rightArrow">
             <a:avLst/>
@@ -23702,8 +23606,8 @@
         </p:nvSpPr>
         <p:spPr>
           <a:xfrm>
-            <a:off x="8878824" y="2331720"/>
-            <a:ext cx="731520" cy="731520"/>
+            <a:off x="8574786" y="2286000"/>
+            <a:ext cx="658368" cy="658368"/>
           </a:xfrm>
           <a:prstGeom prst="ellipse">
             <a:avLst/>
@@ -23729,8 +23633,8 @@
         </p:nvSpPr>
         <p:spPr>
           <a:xfrm>
-            <a:off x="8878824" y="2331720"/>
-            <a:ext cx="731520" cy="731520"/>
+            <a:off x="8574786" y="2286000"/>
+            <a:ext cx="658368" cy="658368"/>
           </a:xfrm>
           <a:prstGeom prst="rect">
             <a:avLst/>
@@ -23768,8 +23672,8 @@
         </p:nvSpPr>
         <p:spPr>
           <a:xfrm>
-            <a:off x="8243316" y="3172968"/>
-            <a:ext cx="2002536" cy="320040"/>
+            <a:off x="8025384" y="3054096"/>
+            <a:ext cx="1757172" cy="320040"/>
           </a:xfrm>
           <a:prstGeom prst="rect">
             <a:avLst/>
@@ -23807,8 +23711,8 @@
         </p:nvSpPr>
         <p:spPr>
           <a:xfrm>
-            <a:off x="8243316" y="3483864"/>
-            <a:ext cx="2002536" cy="822960"/>
+            <a:off x="8025384" y="3364992"/>
+            <a:ext cx="1757172" cy="822960"/>
           </a:xfrm>
           <a:prstGeom prst="rect">
             <a:avLst/>
@@ -23849,8 +23753,8 @@
         </p:nvSpPr>
         <p:spPr>
           <a:xfrm>
-            <a:off x="9646920" y="2615184"/>
-            <a:ext cx="1289304" cy="164592"/>
+            <a:off x="9288018" y="2532888"/>
+            <a:ext cx="1098804" cy="164592"/>
           </a:xfrm>
           <a:prstGeom prst="rightArrow">
             <a:avLst/>
@@ -23869,8 +23773,8 @@
         </p:nvSpPr>
         <p:spPr>
           <a:xfrm>
-            <a:off x="10972800" y="2331720"/>
-            <a:ext cx="731520" cy="731520"/>
+            <a:off x="10441686" y="2286000"/>
+            <a:ext cx="658368" cy="658368"/>
           </a:xfrm>
           <a:prstGeom prst="ellipse">
             <a:avLst/>
@@ -23896,8 +23800,8 @@
         </p:nvSpPr>
         <p:spPr>
           <a:xfrm>
-            <a:off x="10972800" y="2331720"/>
-            <a:ext cx="731520" cy="731520"/>
+            <a:off x="10441686" y="2286000"/>
+            <a:ext cx="658368" cy="658368"/>
           </a:xfrm>
           <a:prstGeom prst="rect">
             <a:avLst/>
@@ -23935,8 +23839,8 @@
         </p:nvSpPr>
         <p:spPr>
           <a:xfrm>
-            <a:off x="10337292" y="3172968"/>
-            <a:ext cx="2002536" cy="320040"/>
+            <a:off x="9892284" y="3054096"/>
+            <a:ext cx="1757172" cy="320040"/>
           </a:xfrm>
           <a:prstGeom prst="rect">
             <a:avLst/>
@@ -23974,8 +23878,8 @@
         </p:nvSpPr>
         <p:spPr>
           <a:xfrm>
-            <a:off x="10337292" y="3483864"/>
-            <a:ext cx="2002536" cy="822960"/>
+            <a:off x="9892284" y="3364992"/>
+            <a:ext cx="1757172" cy="822960"/>
           </a:xfrm>
           <a:prstGeom prst="rect">
             <a:avLst/>
@@ -24297,8 +24201,8 @@
         </p:nvSpPr>
         <p:spPr>
           <a:xfrm>
-            <a:off x="1252728" y="603504"/>
-            <a:ext cx="9966960" cy="548640"/>
+            <a:off x="1252728" y="621792"/>
+            <a:ext cx="10195560" cy="548640"/>
           </a:xfrm>
           <a:prstGeom prst="rect">
             <a:avLst/>
@@ -24314,7 +24218,7 @@
               <a:buNone/>
             </a:pPr>
             <a:r>
-              <a:rPr lang="en-US" sz="2700" b="1" dirty="0">
+              <a:rPr lang="en-US" sz="2500" b="1" dirty="0">
                 <a:solidFill>
                   <a:srgbClr val="2C3E50"/>
                 </a:solidFill>
@@ -24324,7 +24228,7 @@
               </a:rPr>
               <a:t>Criterios de extubación segura</a:t>
             </a:r>
-            <a:endParaRPr lang="en-US" sz="2700" dirty="0"/>
+            <a:endParaRPr lang="en-US" sz="2500" dirty="0"/>
           </a:p>
         </p:txBody>
       </p:sp>
@@ -24455,8 +24359,8 @@
         </p:nvSpPr>
         <p:spPr>
           <a:xfrm>
-            <a:off x="1289304" y="2130552"/>
-            <a:ext cx="2624328" cy="3813048"/>
+            <a:off x="1289304" y="2112264"/>
+            <a:ext cx="2624328" cy="3831336"/>
           </a:xfrm>
           <a:prstGeom prst="rect">
             <a:avLst/>
@@ -24668,8 +24572,8 @@
         </p:nvSpPr>
         <p:spPr>
           <a:xfrm>
-            <a:off x="5020056" y="2130552"/>
-            <a:ext cx="2624328" cy="3813048"/>
+            <a:off x="5020056" y="2112264"/>
+            <a:ext cx="2624328" cy="3831336"/>
           </a:xfrm>
           <a:prstGeom prst="rect">
             <a:avLst/>
@@ -24881,8 +24785,8 @@
         </p:nvSpPr>
         <p:spPr>
           <a:xfrm>
-            <a:off x="8750808" y="2130552"/>
-            <a:ext cx="2624328" cy="3813048"/>
+            <a:off x="8750808" y="2386584"/>
+            <a:ext cx="2624328" cy="3557016"/>
           </a:xfrm>
           <a:prstGeom prst="rect">
             <a:avLst/>
@@ -25175,8 +25079,8 @@
         </p:nvSpPr>
         <p:spPr>
           <a:xfrm>
-            <a:off x="1252728" y="603504"/>
-            <a:ext cx="9966960" cy="548640"/>
+            <a:off x="1252728" y="621792"/>
+            <a:ext cx="10195560" cy="548640"/>
           </a:xfrm>
           <a:prstGeom prst="rect">
             <a:avLst/>
@@ -25192,7 +25096,7 @@
               <a:buNone/>
             </a:pPr>
             <a:r>
-              <a:rPr lang="en-US" sz="2700" b="1" dirty="0">
+              <a:rPr lang="en-US" sz="2500" b="1" dirty="0">
                 <a:solidFill>
                   <a:srgbClr val="2C3E50"/>
                 </a:solidFill>
@@ -25202,7 +25106,7 @@
               </a:rPr>
               <a:t>Técnica y manejo de complicaciones</a:t>
             </a:r>
-            <a:endParaRPr lang="en-US" sz="2700" dirty="0"/>
+            <a:endParaRPr lang="en-US" sz="2500" dirty="0"/>
           </a:p>
         </p:txBody>
       </p:sp>
@@ -25333,8 +25237,8 @@
         </p:nvSpPr>
         <p:spPr>
           <a:xfrm>
-            <a:off x="1289304" y="2130552"/>
-            <a:ext cx="4425696" cy="3813048"/>
+            <a:off x="1289304" y="2112264"/>
+            <a:ext cx="4425696" cy="3831336"/>
           </a:xfrm>
           <a:prstGeom prst="rect">
             <a:avLst/>
@@ -25594,8 +25498,8 @@
         </p:nvSpPr>
         <p:spPr>
           <a:xfrm>
-            <a:off x="6867144" y="2130552"/>
-            <a:ext cx="4636008" cy="3813048"/>
+            <a:off x="6867144" y="2112264"/>
+            <a:ext cx="4636008" cy="3831336"/>
           </a:xfrm>
           <a:prstGeom prst="rect">
             <a:avLst/>
@@ -25912,8 +25816,8 @@
         </p:nvSpPr>
         <p:spPr>
           <a:xfrm>
-            <a:off x="1252728" y="603504"/>
-            <a:ext cx="9966960" cy="548640"/>
+            <a:off x="1252728" y="621792"/>
+            <a:ext cx="10195560" cy="548640"/>
           </a:xfrm>
           <a:prstGeom prst="rect">
             <a:avLst/>
@@ -25929,7 +25833,7 @@
               <a:buNone/>
             </a:pPr>
             <a:r>
-              <a:rPr lang="en-US" sz="2700" b="1" dirty="0">
+              <a:rPr lang="en-US" sz="2500" b="1" dirty="0">
                 <a:solidFill>
                   <a:srgbClr val="2C3E50"/>
                 </a:solidFill>
@@ -25937,9 +25841,9 @@
                 <a:ea typeface="Cambria" pitchFamily="34" charset="-122"/>
                 <a:cs typeface="Cambria" pitchFamily="34" charset="-120"/>
               </a:rPr>
-              <a:t>Poblaciones particulares: pediatría, obesidad y politrauma</a:t>
-            </a:r>
-            <a:endParaRPr lang="en-US" sz="2700" dirty="0"/>
+              <a:t>Pediatría, obesidad y politrauma</a:t>
+            </a:r>
+            <a:endParaRPr lang="en-US" sz="2500" dirty="0"/>
           </a:p>
         </p:txBody>
       </p:sp>
@@ -26070,8 +25974,8 @@
         </p:nvSpPr>
         <p:spPr>
           <a:xfrm>
-            <a:off x="1289304" y="2130552"/>
-            <a:ext cx="2624328" cy="3813048"/>
+            <a:off x="1289304" y="2112264"/>
+            <a:ext cx="2624328" cy="3831336"/>
           </a:xfrm>
           <a:prstGeom prst="rect">
             <a:avLst/>
@@ -26307,8 +26211,8 @@
         </p:nvSpPr>
         <p:spPr>
           <a:xfrm>
-            <a:off x="5020056" y="2130552"/>
-            <a:ext cx="2624328" cy="3813048"/>
+            <a:off x="5020056" y="2112264"/>
+            <a:ext cx="2624328" cy="3831336"/>
           </a:xfrm>
           <a:prstGeom prst="rect">
             <a:avLst/>
@@ -26544,8 +26448,8 @@
         </p:nvSpPr>
         <p:spPr>
           <a:xfrm>
-            <a:off x="8750808" y="2130552"/>
-            <a:ext cx="2624328" cy="3813048"/>
+            <a:off x="8750808" y="2112264"/>
+            <a:ext cx="2624328" cy="3831336"/>
           </a:xfrm>
           <a:prstGeom prst="rect">
             <a:avLst/>
@@ -26862,8 +26766,8 @@
         </p:nvSpPr>
         <p:spPr>
           <a:xfrm>
-            <a:off x="1252728" y="603504"/>
-            <a:ext cx="9966960" cy="548640"/>
+            <a:off x="1252728" y="621792"/>
+            <a:ext cx="10195560" cy="548640"/>
           </a:xfrm>
           <a:prstGeom prst="rect">
             <a:avLst/>
@@ -26879,7 +26783,7 @@
               <a:buNone/>
             </a:pPr>
             <a:r>
-              <a:rPr lang="en-US" sz="2700" b="1" dirty="0">
+              <a:rPr lang="en-US" sz="2500" b="1" dirty="0">
                 <a:solidFill>
                   <a:srgbClr val="2C3E50"/>
                 </a:solidFill>
@@ -26889,7 +26793,7 @@
               </a:rPr>
               <a:t>Complicaciones raras pero graves</a:t>
             </a:r>
-            <a:endParaRPr lang="en-US" sz="2700" dirty="0"/>
+            <a:endParaRPr lang="en-US" sz="2500" dirty="0"/>
           </a:p>
         </p:txBody>
       </p:sp>
@@ -27020,8 +26924,8 @@
         </p:nvSpPr>
         <p:spPr>
           <a:xfrm>
-            <a:off x="1289304" y="2130552"/>
-            <a:ext cx="2624328" cy="1207008"/>
+            <a:off x="1289304" y="2112264"/>
+            <a:ext cx="2624328" cy="1225296"/>
           </a:xfrm>
           <a:prstGeom prst="rect">
             <a:avLst/>
@@ -27184,8 +27088,8 @@
         </p:nvSpPr>
         <p:spPr>
           <a:xfrm>
-            <a:off x="5020056" y="2130552"/>
-            <a:ext cx="2624328" cy="1207008"/>
+            <a:off x="5020056" y="2112264"/>
+            <a:ext cx="2624328" cy="1225296"/>
           </a:xfrm>
           <a:prstGeom prst="rect">
             <a:avLst/>
@@ -27348,8 +27252,8 @@
         </p:nvSpPr>
         <p:spPr>
           <a:xfrm>
-            <a:off x="8750808" y="2130552"/>
-            <a:ext cx="2624328" cy="1207008"/>
+            <a:off x="8750808" y="2386584"/>
+            <a:ext cx="2624328" cy="950976"/>
           </a:xfrm>
           <a:prstGeom prst="rect">
             <a:avLst/>
@@ -27512,8 +27416,8 @@
         </p:nvSpPr>
         <p:spPr>
           <a:xfrm>
-            <a:off x="1289304" y="4279392"/>
-            <a:ext cx="2624328" cy="1207008"/>
+            <a:off x="1289304" y="4535424"/>
+            <a:ext cx="2624328" cy="950976"/>
           </a:xfrm>
           <a:prstGeom prst="rect">
             <a:avLst/>
@@ -27676,8 +27580,8 @@
         </p:nvSpPr>
         <p:spPr>
           <a:xfrm>
-            <a:off x="5020056" y="4279392"/>
-            <a:ext cx="2624328" cy="1207008"/>
+            <a:off x="5020056" y="4261104"/>
+            <a:ext cx="2624328" cy="1225296"/>
           </a:xfrm>
           <a:prstGeom prst="rect">
             <a:avLst/>
@@ -27840,8 +27744,8 @@
         </p:nvSpPr>
         <p:spPr>
           <a:xfrm>
-            <a:off x="8750808" y="4279392"/>
-            <a:ext cx="2624328" cy="1207008"/>
+            <a:off x="8750808" y="4535424"/>
+            <a:ext cx="2624328" cy="950976"/>
           </a:xfrm>
           <a:prstGeom prst="rect">
             <a:avLst/>
@@ -28085,8 +27989,8 @@
         </p:nvSpPr>
         <p:spPr>
           <a:xfrm>
-            <a:off x="1252728" y="603504"/>
-            <a:ext cx="9966960" cy="548640"/>
+            <a:off x="1252728" y="621792"/>
+            <a:ext cx="10195560" cy="548640"/>
           </a:xfrm>
           <a:prstGeom prst="rect">
             <a:avLst/>
@@ -28102,7 +28006,7 @@
               <a:buNone/>
             </a:pPr>
             <a:r>
-              <a:rPr lang="en-US" sz="2700" b="1" dirty="0">
+              <a:rPr lang="en-US" sz="2500" b="1" dirty="0">
                 <a:solidFill>
                   <a:srgbClr val="2C3E50"/>
                 </a:solidFill>
@@ -28112,7 +28016,7 @@
               </a:rPr>
               <a:t>Definición de la intubación traqueal</a:t>
             </a:r>
-            <a:endParaRPr lang="en-US" sz="2700" dirty="0"/>
+            <a:endParaRPr lang="en-US" sz="2500" dirty="0"/>
           </a:p>
         </p:txBody>
       </p:sp>
@@ -28209,26 +28113,26 @@
         <p:spPr>
           <a:xfrm>
             <a:off x="777240" y="3657600"/>
-            <a:ext cx="9052560" cy="640080"/>
-          </a:xfrm>
-          <a:prstGeom prst="rect">
-            <a:avLst/>
-          </a:prstGeom>
-          <a:noFill/>
-          <a:ln/>
-        </p:spPr>
-        <p:txBody>
-          <a:bodyPr wrap="square" lIns="0" tIns="0" rIns="0" bIns="0" rtlCol="0" anchor="ctr"/>
+            <a:ext cx="6126480" cy="777240"/>
+          </a:xfrm>
+          <a:prstGeom prst="rect">
+            <a:avLst/>
+          </a:prstGeom>
+          <a:noFill/>
+          <a:ln/>
+        </p:spPr>
+        <p:txBody>
+          <a:bodyPr wrap="square" lIns="0" tIns="0" rIns="0" bIns="0" rtlCol="0" anchor="t"/>
           <a:lstStyle/>
           <a:p>
             <a:pPr indent="0" marL="0">
               <a:lnSpc>
-                <a:spcPts val="1700"/>
+                <a:spcPts val="1600"/>
               </a:lnSpc>
               <a:buNone/>
             </a:pPr>
             <a:r>
-              <a:rPr lang="en-US" sz="1350" b="1" dirty="0">
+              <a:rPr lang="en-US" sz="1250" b="1" dirty="0">
                 <a:solidFill>
                   <a:srgbClr val="2C3E50"/>
                 </a:solidFill>
@@ -28238,39 +28142,14 @@
               </a:rPr>
               <a:t>Vía de acceso:  </a:t>
             </a:r>
-            <a:endParaRPr lang="en-US" sz="1350" dirty="0"/>
-          </a:p>
-        </p:txBody>
-      </p:sp>
-      <p:sp>
-        <p:nvSpPr>
-          <p:cNvPr id="10" name="Text 7"/>
-          <p:cNvSpPr txBox="1"/>
-          <p:nvPr/>
-        </p:nvSpPr>
-        <p:spPr>
-          <a:xfrm>
-            <a:off x="777240" y="3657600"/>
-            <a:ext cx="9098280" cy="685800"/>
-          </a:xfrm>
-          <a:prstGeom prst="rect">
-            <a:avLst/>
-          </a:prstGeom>
-          <a:noFill/>
-          <a:ln/>
-        </p:spPr>
-        <p:txBody>
-          <a:bodyPr wrap="square" lIns="0" tIns="0" rIns="0" bIns="0" rtlCol="0" anchor="t"/>
-          <a:lstStyle/>
-          <a:p>
             <a:pPr indent="0" marL="0">
               <a:lnSpc>
-                <a:spcPts val="1700"/>
+                <a:spcPts val="1600"/>
               </a:lnSpc>
               <a:buNone/>
             </a:pPr>
             <a:r>
-              <a:rPr lang="en-US" sz="1350" b="1" dirty="0">
+              <a:rPr lang="en-US" sz="1250" dirty="0">
                 <a:solidFill>
                   <a:srgbClr val="2C3E50"/>
                 </a:solidFill>
@@ -28278,32 +28157,15 @@
                 <a:ea typeface="Calibri" pitchFamily="34" charset="-122"/>
                 <a:cs typeface="Calibri" pitchFamily="34" charset="-120"/>
               </a:rPr>
-              <a:t>Vía de acceso:  </a:t>
-            </a:r>
-            <a:pPr indent="0" marL="0">
-              <a:lnSpc>
-                <a:spcPts val="1700"/>
-              </a:lnSpc>
-              <a:buNone/>
-            </a:pPr>
-            <a:r>
-              <a:rPr lang="en-US" sz="1350" dirty="0">
-                <a:solidFill>
-                  <a:srgbClr val="2C3E50"/>
-                </a:solidFill>
-                <a:latin typeface="Calibri" pitchFamily="34" charset="0"/>
-                <a:ea typeface="Calibri" pitchFamily="34" charset="-122"/>
-                <a:cs typeface="Calibri" pitchFamily="34" charset="-120"/>
-              </a:rPr>
               <a:t>Puede realizarse por vía orotraqueal (la más frecuente) o nasotraqueal, según la indicación clínica y quirúrgica.</a:t>
             </a:r>
-            <a:endParaRPr lang="en-US" sz="1350" dirty="0"/>
-          </a:p>
-        </p:txBody>
-      </p:sp>
-      <p:sp>
-        <p:nvSpPr>
-          <p:cNvPr id="11" name="Shape 8"/>
+            <a:endParaRPr lang="en-US" sz="1250" dirty="0"/>
+          </a:p>
+        </p:txBody>
+      </p:sp>
+      <p:sp>
+        <p:nvSpPr>
+          <p:cNvPr id="10" name="Shape 7"/>
           <p:cNvSpPr/>
           <p:nvPr/>
         </p:nvSpPr>
@@ -28323,33 +28185,33 @@
       </p:sp>
       <p:sp>
         <p:nvSpPr>
-          <p:cNvPr id="12" name="Text 9"/>
+          <p:cNvPr id="11" name="Text 8"/>
           <p:cNvSpPr txBox="1"/>
           <p:nvPr/>
         </p:nvSpPr>
         <p:spPr>
           <a:xfrm>
             <a:off x="777240" y="4498848"/>
-            <a:ext cx="9052560" cy="640080"/>
-          </a:xfrm>
-          <a:prstGeom prst="rect">
-            <a:avLst/>
-          </a:prstGeom>
-          <a:noFill/>
-          <a:ln/>
-        </p:spPr>
-        <p:txBody>
-          <a:bodyPr wrap="square" lIns="0" tIns="0" rIns="0" bIns="0" rtlCol="0" anchor="ctr"/>
+            <a:ext cx="6126480" cy="777240"/>
+          </a:xfrm>
+          <a:prstGeom prst="rect">
+            <a:avLst/>
+          </a:prstGeom>
+          <a:noFill/>
+          <a:ln/>
+        </p:spPr>
+        <p:txBody>
+          <a:bodyPr wrap="square" lIns="0" tIns="0" rIns="0" bIns="0" rtlCol="0" anchor="t"/>
           <a:lstStyle/>
           <a:p>
             <a:pPr indent="0" marL="0">
               <a:lnSpc>
-                <a:spcPts val="1700"/>
+                <a:spcPts val="1600"/>
               </a:lnSpc>
               <a:buNone/>
             </a:pPr>
             <a:r>
-              <a:rPr lang="en-US" sz="1350" b="1" dirty="0">
+              <a:rPr lang="en-US" sz="1250" b="1" dirty="0">
                 <a:solidFill>
                   <a:srgbClr val="2C3E50"/>
                 </a:solidFill>
@@ -28359,39 +28221,14 @@
               </a:rPr>
               <a:t>Instrumento clave:  </a:t>
             </a:r>
-            <a:endParaRPr lang="en-US" sz="1350" dirty="0"/>
-          </a:p>
-        </p:txBody>
-      </p:sp>
-      <p:sp>
-        <p:nvSpPr>
-          <p:cNvPr id="13" name="Text 10"/>
-          <p:cNvSpPr txBox="1"/>
-          <p:nvPr/>
-        </p:nvSpPr>
-        <p:spPr>
-          <a:xfrm>
-            <a:off x="777240" y="4498848"/>
-            <a:ext cx="9098280" cy="685800"/>
-          </a:xfrm>
-          <a:prstGeom prst="rect">
-            <a:avLst/>
-          </a:prstGeom>
-          <a:noFill/>
-          <a:ln/>
-        </p:spPr>
-        <p:txBody>
-          <a:bodyPr wrap="square" lIns="0" tIns="0" rIns="0" bIns="0" rtlCol="0" anchor="t"/>
-          <a:lstStyle/>
-          <a:p>
             <a:pPr indent="0" marL="0">
               <a:lnSpc>
-                <a:spcPts val="1700"/>
+                <a:spcPts val="1600"/>
               </a:lnSpc>
               <a:buNone/>
             </a:pPr>
             <a:r>
-              <a:rPr lang="en-US" sz="1350" b="1" dirty="0">
+              <a:rPr lang="en-US" sz="1250" dirty="0">
                 <a:solidFill>
                   <a:srgbClr val="2C3E50"/>
                 </a:solidFill>
@@ -28399,32 +28236,15 @@
                 <a:ea typeface="Calibri" pitchFamily="34" charset="-122"/>
                 <a:cs typeface="Calibri" pitchFamily="34" charset="-120"/>
               </a:rPr>
-              <a:t>Instrumento clave:  </a:t>
-            </a:r>
-            <a:pPr indent="0" marL="0">
-              <a:lnSpc>
-                <a:spcPts val="1700"/>
-              </a:lnSpc>
-              <a:buNone/>
-            </a:pPr>
-            <a:r>
-              <a:rPr lang="en-US" sz="1350" dirty="0">
-                <a:solidFill>
-                  <a:srgbClr val="2C3E50"/>
-                </a:solidFill>
-                <a:latin typeface="Calibri" pitchFamily="34" charset="0"/>
-                <a:ea typeface="Calibri" pitchFamily="34" charset="-122"/>
-                <a:cs typeface="Calibri" pitchFamily="34" charset="-120"/>
-              </a:rPr>
               <a:t>El tubo endotraqueal (TET) queda situado entre la glotis y la carina, habitualmente con su extremo distal 2-4 cm por encima de la carina.</a:t>
             </a:r>
-            <a:endParaRPr lang="en-US" sz="1350" dirty="0"/>
-          </a:p>
-        </p:txBody>
-      </p:sp>
-      <p:sp>
-        <p:nvSpPr>
-          <p:cNvPr id="14" name="Shape 11"/>
+            <a:endParaRPr lang="en-US" sz="1250" dirty="0"/>
+          </a:p>
+        </p:txBody>
+      </p:sp>
+      <p:sp>
+        <p:nvSpPr>
+          <p:cNvPr id="12" name="Shape 9"/>
           <p:cNvSpPr/>
           <p:nvPr/>
         </p:nvSpPr>
@@ -28444,33 +28264,33 @@
       </p:sp>
       <p:sp>
         <p:nvSpPr>
-          <p:cNvPr id="15" name="Text 12"/>
+          <p:cNvPr id="13" name="Text 10"/>
           <p:cNvSpPr txBox="1"/>
           <p:nvPr/>
         </p:nvSpPr>
         <p:spPr>
           <a:xfrm>
             <a:off x="777240" y="5340096"/>
-            <a:ext cx="9052560" cy="640080"/>
-          </a:xfrm>
-          <a:prstGeom prst="rect">
-            <a:avLst/>
-          </a:prstGeom>
-          <a:noFill/>
-          <a:ln/>
-        </p:spPr>
-        <p:txBody>
-          <a:bodyPr wrap="square" lIns="0" tIns="0" rIns="0" bIns="0" rtlCol="0" anchor="ctr"/>
+            <a:ext cx="6126480" cy="777240"/>
+          </a:xfrm>
+          <a:prstGeom prst="rect">
+            <a:avLst/>
+          </a:prstGeom>
+          <a:noFill/>
+          <a:ln/>
+        </p:spPr>
+        <p:txBody>
+          <a:bodyPr wrap="square" lIns="0" tIns="0" rIns="0" bIns="0" rtlCol="0" anchor="t"/>
           <a:lstStyle/>
           <a:p>
             <a:pPr indent="0" marL="0">
               <a:lnSpc>
-                <a:spcPts val="1700"/>
+                <a:spcPts val="1600"/>
               </a:lnSpc>
               <a:buNone/>
             </a:pPr>
             <a:r>
-              <a:rPr lang="en-US" sz="1350" b="1" dirty="0">
+              <a:rPr lang="en-US" sz="1250" b="1" dirty="0">
                 <a:solidFill>
                   <a:srgbClr val="2C3E50"/>
                 </a:solidFill>
@@ -28480,39 +28300,14 @@
               </a:rPr>
               <a:t>Pilar de la anestesiología:  </a:t>
             </a:r>
-            <a:endParaRPr lang="en-US" sz="1350" dirty="0"/>
-          </a:p>
-        </p:txBody>
-      </p:sp>
-      <p:sp>
-        <p:nvSpPr>
-          <p:cNvPr id="16" name="Text 13"/>
-          <p:cNvSpPr txBox="1"/>
-          <p:nvPr/>
-        </p:nvSpPr>
-        <p:spPr>
-          <a:xfrm>
-            <a:off x="777240" y="5340096"/>
-            <a:ext cx="9098280" cy="685800"/>
-          </a:xfrm>
-          <a:prstGeom prst="rect">
-            <a:avLst/>
-          </a:prstGeom>
-          <a:noFill/>
-          <a:ln/>
-        </p:spPr>
-        <p:txBody>
-          <a:bodyPr wrap="square" lIns="0" tIns="0" rIns="0" bIns="0" rtlCol="0" anchor="t"/>
-          <a:lstStyle/>
-          <a:p>
             <a:pPr indent="0" marL="0">
               <a:lnSpc>
-                <a:spcPts val="1700"/>
+                <a:spcPts val="1600"/>
               </a:lnSpc>
               <a:buNone/>
             </a:pPr>
             <a:r>
-              <a:rPr lang="en-US" sz="1350" b="1" dirty="0">
+              <a:rPr lang="en-US" sz="1250" dirty="0">
                 <a:solidFill>
                   <a:srgbClr val="2C3E50"/>
                 </a:solidFill>
@@ -28520,32 +28315,15 @@
                 <a:ea typeface="Calibri" pitchFamily="34" charset="-122"/>
                 <a:cs typeface="Calibri" pitchFamily="34" charset="-120"/>
               </a:rPr>
-              <a:t>Pilar de la anestesiología:  </a:t>
-            </a:r>
-            <a:pPr indent="0" marL="0">
-              <a:lnSpc>
-                <a:spcPts val="1700"/>
-              </a:lnSpc>
-              <a:buNone/>
-            </a:pPr>
-            <a:r>
-              <a:rPr lang="en-US" sz="1350" dirty="0">
-                <a:solidFill>
-                  <a:srgbClr val="2C3E50"/>
-                </a:solidFill>
-                <a:latin typeface="Calibri" pitchFamily="34" charset="0"/>
-                <a:ea typeface="Calibri" pitchFamily="34" charset="-122"/>
-                <a:cs typeface="Calibri" pitchFamily="34" charset="-120"/>
-              </a:rPr>
               <a:t>Es la técnica de referencia para el control definitivo de la vía aérea en anestesia general y en reanimación.</a:t>
             </a:r>
-            <a:endParaRPr lang="en-US" sz="1350" dirty="0"/>
-          </a:p>
-        </p:txBody>
-      </p:sp>
-      <p:sp>
-        <p:nvSpPr>
-          <p:cNvPr id="17" name="Shape 14"/>
+            <a:endParaRPr lang="en-US" sz="1250" dirty="0"/>
+          </a:p>
+        </p:txBody>
+      </p:sp>
+      <p:sp>
+        <p:nvSpPr>
+          <p:cNvPr id="14" name="Shape 11"/>
           <p:cNvSpPr/>
           <p:nvPr/>
         </p:nvSpPr>
@@ -28574,7 +28352,7 @@
       </p:sp>
       <p:sp>
         <p:nvSpPr>
-          <p:cNvPr id="18" name="Shape 15"/>
+          <p:cNvPr id="15" name="Shape 12"/>
           <p:cNvSpPr/>
           <p:nvPr/>
         </p:nvSpPr>
@@ -28601,7 +28379,7 @@
       </p:sp>
       <p:pic>
         <p:nvPicPr>
-          <p:cNvPr id="19" name="Image 1" descr="preencoded.png">    </p:cNvPr>
+          <p:cNvPr id="16" name="Image 1" descr="preencoded.png">    </p:cNvPr>
           <p:cNvPicPr>
             <a:picLocks noChangeAspect="1"/>
           </p:cNvPicPr>
@@ -28625,7 +28403,7 @@
       </p:pic>
       <p:sp>
         <p:nvSpPr>
-          <p:cNvPr id="20" name="Text 16"/>
+          <p:cNvPr id="17" name="Text 13"/>
           <p:cNvSpPr txBox="1"/>
           <p:nvPr/>
         </p:nvSpPr>
@@ -28664,14 +28442,14 @@
       </p:sp>
       <p:sp>
         <p:nvSpPr>
-          <p:cNvPr id="21" name="Text 17"/>
-          <p:cNvSpPr txBox="1"/>
-          <p:nvPr/>
-        </p:nvSpPr>
-        <p:spPr>
-          <a:xfrm>
-            <a:off x="7964424" y="2130552"/>
-            <a:ext cx="3511296" cy="3813048"/>
+          <p:cNvPr id="18" name="Text 14"/>
+          <p:cNvSpPr txBox="1"/>
+          <p:nvPr/>
+        </p:nvSpPr>
+        <p:spPr>
+          <a:xfrm>
+            <a:off x="7964424" y="2386584"/>
+            <a:ext cx="3511296" cy="3557016"/>
           </a:xfrm>
           <a:prstGeom prst="rect">
             <a:avLst/>
@@ -28782,7 +28560,7 @@
       </p:sp>
       <p:sp>
         <p:nvSpPr>
-          <p:cNvPr id="23" name="Text 18"/>
+          <p:cNvPr id="20" name="Text 15"/>
           <p:cNvSpPr txBox="1"/>
           <p:nvPr/>
         </p:nvSpPr>
@@ -28821,7 +28599,7 @@
       </p:sp>
       <p:sp>
         <p:nvSpPr>
-          <p:cNvPr id="24" name="Text 19"/>
+          <p:cNvPr id="21" name="Text 16"/>
           <p:cNvSpPr txBox="1"/>
           <p:nvPr/>
         </p:nvSpPr>
@@ -30836,8 +30614,8 @@
         </p:nvSpPr>
         <p:spPr>
           <a:xfrm>
-            <a:off x="1252728" y="603504"/>
-            <a:ext cx="9966960" cy="548640"/>
+            <a:off x="1252728" y="621792"/>
+            <a:ext cx="10195560" cy="548640"/>
           </a:xfrm>
           <a:prstGeom prst="rect">
             <a:avLst/>
@@ -30853,7 +30631,7 @@
               <a:buNone/>
             </a:pPr>
             <a:r>
-              <a:rPr lang="en-US" sz="2700" b="1" dirty="0">
+              <a:rPr lang="en-US" sz="2500" b="1" dirty="0">
                 <a:solidFill>
                   <a:srgbClr val="2C3E50"/>
                 </a:solidFill>
@@ -30863,7 +30641,7 @@
               </a:rPr>
               <a:t>Historia de la intubación traqueal</a:t>
             </a:r>
-            <a:endParaRPr lang="en-US" sz="2700" dirty="0"/>
+            <a:endParaRPr lang="en-US" sz="2500" dirty="0"/>
           </a:p>
         </p:txBody>
       </p:sp>
@@ -30875,7 +30653,7 @@
         </p:nvSpPr>
         <p:spPr>
           <a:xfrm>
-            <a:off x="1417320" y="1709928"/>
+            <a:off x="2084832" y="1709928"/>
             <a:ext cx="0" cy="3794760"/>
           </a:xfrm>
           <a:prstGeom prst="line">
@@ -30898,7 +30676,7 @@
         </p:nvSpPr>
         <p:spPr>
           <a:xfrm>
-            <a:off x="1298448" y="1618488"/>
+            <a:off x="1965960" y="1618488"/>
             <a:ext cx="237744" cy="237744"/>
           </a:xfrm>
           <a:prstGeom prst="ellipse">
@@ -30923,24 +30701,24 @@
         </p:nvSpPr>
         <p:spPr>
           <a:xfrm>
-            <a:off x="502920" y="1545336"/>
-            <a:ext cx="731520" cy="365760"/>
-          </a:xfrm>
-          <a:prstGeom prst="rect">
-            <a:avLst/>
-          </a:prstGeom>
-          <a:noFill/>
-          <a:ln/>
-        </p:spPr>
-        <p:txBody>
-          <a:bodyPr wrap="square" lIns="0" tIns="0" rIns="0" bIns="0" rtlCol="0" anchor="ctr"/>
+            <a:off x="502920" y="1591056"/>
+            <a:ext cx="1371600" cy="274320"/>
+          </a:xfrm>
+          <a:prstGeom prst="rect">
+            <a:avLst/>
+          </a:prstGeom>
+          <a:noFill/>
+          <a:ln/>
+        </p:spPr>
+        <p:txBody>
+          <a:bodyPr wrap="none" lIns="0" tIns="0" rIns="0" bIns="0" rtlCol="0" anchor="t"/>
           <a:lstStyle/>
           <a:p>
             <a:pPr algn="r" indent="0" marL="0">
               <a:buNone/>
             </a:pPr>
             <a:r>
-              <a:rPr lang="en-US" sz="1250" b="1" dirty="0">
+              <a:rPr lang="en-US" sz="1100" b="1" dirty="0">
                 <a:solidFill>
                   <a:srgbClr val="128A9C"/>
                 </a:solidFill>
@@ -30950,7 +30728,7 @@
               </a:rPr>
               <a:t>Siglo XVI</a:t>
             </a:r>
-            <a:endParaRPr lang="en-US" sz="1250" dirty="0"/>
+            <a:endParaRPr lang="en-US" sz="1100" dirty="0"/>
           </a:p>
         </p:txBody>
       </p:sp>
@@ -30962,8 +30740,8 @@
         </p:nvSpPr>
         <p:spPr>
           <a:xfrm>
-            <a:off x="1783080" y="1508760"/>
-            <a:ext cx="9875520" cy="658368"/>
+            <a:off x="2468880" y="1508760"/>
+            <a:ext cx="9189720" cy="658368"/>
           </a:xfrm>
           <a:prstGeom prst="rect">
             <a:avLst/>
@@ -31004,7 +30782,7 @@
         </p:nvSpPr>
         <p:spPr>
           <a:xfrm>
-            <a:off x="1298448" y="2368296"/>
+            <a:off x="1965960" y="2368296"/>
             <a:ext cx="237744" cy="237744"/>
           </a:xfrm>
           <a:prstGeom prst="ellipse">
@@ -31029,24 +30807,24 @@
         </p:nvSpPr>
         <p:spPr>
           <a:xfrm>
-            <a:off x="502920" y="2295144"/>
-            <a:ext cx="731520" cy="365760"/>
-          </a:xfrm>
-          <a:prstGeom prst="rect">
-            <a:avLst/>
-          </a:prstGeom>
-          <a:noFill/>
-          <a:ln/>
-        </p:spPr>
-        <p:txBody>
-          <a:bodyPr wrap="square" lIns="0" tIns="0" rIns="0" bIns="0" rtlCol="0" anchor="ctr"/>
+            <a:off x="502920" y="2340864"/>
+            <a:ext cx="1371600" cy="274320"/>
+          </a:xfrm>
+          <a:prstGeom prst="rect">
+            <a:avLst/>
+          </a:prstGeom>
+          <a:noFill/>
+          <a:ln/>
+        </p:spPr>
+        <p:txBody>
+          <a:bodyPr wrap="none" lIns="0" tIns="0" rIns="0" bIns="0" rtlCol="0" anchor="t"/>
           <a:lstStyle/>
           <a:p>
             <a:pPr algn="r" indent="0" marL="0">
               <a:buNone/>
             </a:pPr>
             <a:r>
-              <a:rPr lang="en-US" sz="1250" b="1" dirty="0">
+              <a:rPr lang="en-US" sz="1100" b="1" dirty="0">
                 <a:solidFill>
                   <a:srgbClr val="128A9C"/>
                 </a:solidFill>
@@ -31056,7 +30834,7 @@
               </a:rPr>
               <a:t>1880s</a:t>
             </a:r>
-            <a:endParaRPr lang="en-US" sz="1250" dirty="0"/>
+            <a:endParaRPr lang="en-US" sz="1100" dirty="0"/>
           </a:p>
         </p:txBody>
       </p:sp>
@@ -31068,8 +30846,8 @@
         </p:nvSpPr>
         <p:spPr>
           <a:xfrm>
-            <a:off x="1783080" y="2258568"/>
-            <a:ext cx="9875520" cy="658368"/>
+            <a:off x="2468880" y="2258568"/>
+            <a:ext cx="9189720" cy="658368"/>
           </a:xfrm>
           <a:prstGeom prst="rect">
             <a:avLst/>
@@ -31110,7 +30888,7 @@
         </p:nvSpPr>
         <p:spPr>
           <a:xfrm>
-            <a:off x="1298448" y="3118104"/>
+            <a:off x="1965960" y="3118104"/>
             <a:ext cx="237744" cy="237744"/>
           </a:xfrm>
           <a:prstGeom prst="ellipse">
@@ -31135,24 +30913,24 @@
         </p:nvSpPr>
         <p:spPr>
           <a:xfrm>
-            <a:off x="502920" y="3044952"/>
-            <a:ext cx="731520" cy="365760"/>
-          </a:xfrm>
-          <a:prstGeom prst="rect">
-            <a:avLst/>
-          </a:prstGeom>
-          <a:noFill/>
-          <a:ln/>
-        </p:spPr>
-        <p:txBody>
-          <a:bodyPr wrap="square" lIns="0" tIns="0" rIns="0" bIns="0" rtlCol="0" anchor="ctr"/>
+            <a:off x="502920" y="3090672"/>
+            <a:ext cx="1371600" cy="274320"/>
+          </a:xfrm>
+          <a:prstGeom prst="rect">
+            <a:avLst/>
+          </a:prstGeom>
+          <a:noFill/>
+          <a:ln/>
+        </p:spPr>
+        <p:txBody>
+          <a:bodyPr wrap="none" lIns="0" tIns="0" rIns="0" bIns="0" rtlCol="0" anchor="t"/>
           <a:lstStyle/>
           <a:p>
             <a:pPr algn="r" indent="0" marL="0">
               <a:buNone/>
             </a:pPr>
             <a:r>
-              <a:rPr lang="en-US" sz="1250" b="1" dirty="0">
+              <a:rPr lang="en-US" sz="1100" b="1" dirty="0">
                 <a:solidFill>
                   <a:srgbClr val="128A9C"/>
                 </a:solidFill>
@@ -31162,7 +30940,7 @@
               </a:rPr>
               <a:t>1913</a:t>
             </a:r>
-            <a:endParaRPr lang="en-US" sz="1250" dirty="0"/>
+            <a:endParaRPr lang="en-US" sz="1100" dirty="0"/>
           </a:p>
         </p:txBody>
       </p:sp>
@@ -31174,8 +30952,8 @@
         </p:nvSpPr>
         <p:spPr>
           <a:xfrm>
-            <a:off x="1783080" y="3008376"/>
-            <a:ext cx="9875520" cy="658368"/>
+            <a:off x="2468880" y="3008376"/>
+            <a:ext cx="9189720" cy="658368"/>
           </a:xfrm>
           <a:prstGeom prst="rect">
             <a:avLst/>
@@ -31216,7 +30994,7 @@
         </p:nvSpPr>
         <p:spPr>
           <a:xfrm>
-            <a:off x="1298448" y="3867912"/>
+            <a:off x="1965960" y="3867912"/>
             <a:ext cx="237744" cy="237744"/>
           </a:xfrm>
           <a:prstGeom prst="ellipse">
@@ -31241,24 +31019,24 @@
         </p:nvSpPr>
         <p:spPr>
           <a:xfrm>
-            <a:off x="502920" y="3794760"/>
-            <a:ext cx="731520" cy="365760"/>
-          </a:xfrm>
-          <a:prstGeom prst="rect">
-            <a:avLst/>
-          </a:prstGeom>
-          <a:noFill/>
-          <a:ln/>
-        </p:spPr>
-        <p:txBody>
-          <a:bodyPr wrap="square" lIns="0" tIns="0" rIns="0" bIns="0" rtlCol="0" anchor="ctr"/>
+            <a:off x="502920" y="3840480"/>
+            <a:ext cx="1371600" cy="274320"/>
+          </a:xfrm>
+          <a:prstGeom prst="rect">
+            <a:avLst/>
+          </a:prstGeom>
+          <a:noFill/>
+          <a:ln/>
+        </p:spPr>
+        <p:txBody>
+          <a:bodyPr wrap="none" lIns="0" tIns="0" rIns="0" bIns="0" rtlCol="0" anchor="t"/>
           <a:lstStyle/>
           <a:p>
             <a:pPr algn="r" indent="0" marL="0">
               <a:buNone/>
             </a:pPr>
             <a:r>
-              <a:rPr lang="en-US" sz="1250" b="1" dirty="0">
+              <a:rPr lang="en-US" sz="1100" b="1" dirty="0">
                 <a:solidFill>
                   <a:srgbClr val="128A9C"/>
                 </a:solidFill>
@@ -31268,7 +31046,7 @@
               </a:rPr>
               <a:t>1920-1930</a:t>
             </a:r>
-            <a:endParaRPr lang="en-US" sz="1250" dirty="0"/>
+            <a:endParaRPr lang="en-US" sz="1100" dirty="0"/>
           </a:p>
         </p:txBody>
       </p:sp>
@@ -31280,8 +31058,8 @@
         </p:nvSpPr>
         <p:spPr>
           <a:xfrm>
-            <a:off x="1783080" y="3758184"/>
-            <a:ext cx="9875520" cy="658368"/>
+            <a:off x="2468880" y="3758184"/>
+            <a:ext cx="9189720" cy="658368"/>
           </a:xfrm>
           <a:prstGeom prst="rect">
             <a:avLst/>
@@ -31322,7 +31100,7 @@
         </p:nvSpPr>
         <p:spPr>
           <a:xfrm>
-            <a:off x="1298448" y="4617720"/>
+            <a:off x="1965960" y="4617720"/>
             <a:ext cx="237744" cy="237744"/>
           </a:xfrm>
           <a:prstGeom prst="ellipse">
@@ -31347,24 +31125,24 @@
         </p:nvSpPr>
         <p:spPr>
           <a:xfrm>
-            <a:off x="502920" y="4544568"/>
-            <a:ext cx="731520" cy="365760"/>
-          </a:xfrm>
-          <a:prstGeom prst="rect">
-            <a:avLst/>
-          </a:prstGeom>
-          <a:noFill/>
-          <a:ln/>
-        </p:spPr>
-        <p:txBody>
-          <a:bodyPr wrap="square" lIns="0" tIns="0" rIns="0" bIns="0" rtlCol="0" anchor="ctr"/>
+            <a:off x="502920" y="4590288"/>
+            <a:ext cx="1371600" cy="274320"/>
+          </a:xfrm>
+          <a:prstGeom prst="rect">
+            <a:avLst/>
+          </a:prstGeom>
+          <a:noFill/>
+          <a:ln/>
+        </p:spPr>
+        <p:txBody>
+          <a:bodyPr wrap="none" lIns="0" tIns="0" rIns="0" bIns="0" rtlCol="0" anchor="t"/>
           <a:lstStyle/>
           <a:p>
             <a:pPr algn="r" indent="0" marL="0">
               <a:buNone/>
             </a:pPr>
             <a:r>
-              <a:rPr lang="en-US" sz="1250" b="1" dirty="0">
+              <a:rPr lang="en-US" sz="1100" b="1" dirty="0">
                 <a:solidFill>
                   <a:srgbClr val="128A9C"/>
                 </a:solidFill>
@@ -31374,7 +31152,7 @@
               </a:rPr>
               <a:t>1940s</a:t>
             </a:r>
-            <a:endParaRPr lang="en-US" sz="1250" dirty="0"/>
+            <a:endParaRPr lang="en-US" sz="1100" dirty="0"/>
           </a:p>
         </p:txBody>
       </p:sp>
@@ -31386,8 +31164,8 @@
         </p:nvSpPr>
         <p:spPr>
           <a:xfrm>
-            <a:off x="1783080" y="4507992"/>
-            <a:ext cx="9875520" cy="658368"/>
+            <a:off x="2468880" y="4507992"/>
+            <a:ext cx="9189720" cy="658368"/>
           </a:xfrm>
           <a:prstGeom prst="rect">
             <a:avLst/>
@@ -31428,7 +31206,7 @@
         </p:nvSpPr>
         <p:spPr>
           <a:xfrm>
-            <a:off x="1298448" y="5367528"/>
+            <a:off x="1965960" y="5367528"/>
             <a:ext cx="237744" cy="237744"/>
           </a:xfrm>
           <a:prstGeom prst="ellipse">
@@ -31453,24 +31231,24 @@
         </p:nvSpPr>
         <p:spPr>
           <a:xfrm>
-            <a:off x="502920" y="5294376"/>
-            <a:ext cx="731520" cy="365760"/>
-          </a:xfrm>
-          <a:prstGeom prst="rect">
-            <a:avLst/>
-          </a:prstGeom>
-          <a:noFill/>
-          <a:ln/>
-        </p:spPr>
-        <p:txBody>
-          <a:bodyPr wrap="square" lIns="0" tIns="0" rIns="0" bIns="0" rtlCol="0" anchor="ctr"/>
+            <a:off x="502920" y="5340096"/>
+            <a:ext cx="1371600" cy="274320"/>
+          </a:xfrm>
+          <a:prstGeom prst="rect">
+            <a:avLst/>
+          </a:prstGeom>
+          <a:noFill/>
+          <a:ln/>
+        </p:spPr>
+        <p:txBody>
+          <a:bodyPr wrap="none" lIns="0" tIns="0" rIns="0" bIns="0" rtlCol="0" anchor="t"/>
           <a:lstStyle/>
           <a:p>
             <a:pPr algn="r" indent="0" marL="0">
               <a:buNone/>
             </a:pPr>
             <a:r>
-              <a:rPr lang="en-US" sz="1250" b="1" dirty="0">
+              <a:rPr lang="en-US" sz="1100" b="1" dirty="0">
                 <a:solidFill>
                   <a:srgbClr val="128A9C"/>
                 </a:solidFill>
@@ -31480,7 +31258,7 @@
               </a:rPr>
               <a:t>Actualidad</a:t>
             </a:r>
-            <a:endParaRPr lang="en-US" sz="1250" dirty="0"/>
+            <a:endParaRPr lang="en-US" sz="1100" dirty="0"/>
           </a:p>
         </p:txBody>
       </p:sp>
@@ -31492,8 +31270,8 @@
         </p:nvSpPr>
         <p:spPr>
           <a:xfrm>
-            <a:off x="1783080" y="5257800"/>
-            <a:ext cx="9875520" cy="658368"/>
+            <a:off x="2468880" y="5257800"/>
+            <a:ext cx="9189720" cy="658368"/>
           </a:xfrm>
           <a:prstGeom prst="rect">
             <a:avLst/>
@@ -31815,8 +31593,8 @@
         </p:nvSpPr>
         <p:spPr>
           <a:xfrm>
-            <a:off x="1252728" y="603504"/>
-            <a:ext cx="9966960" cy="548640"/>
+            <a:off x="1252728" y="621792"/>
+            <a:ext cx="10195560" cy="548640"/>
           </a:xfrm>
           <a:prstGeom prst="rect">
             <a:avLst/>
@@ -31832,7 +31610,7 @@
               <a:buNone/>
             </a:pPr>
             <a:r>
-              <a:rPr lang="en-US" sz="2700" b="1" dirty="0">
+              <a:rPr lang="en-US" sz="2500" b="1" dirty="0">
                 <a:solidFill>
                   <a:srgbClr val="2C3E50"/>
                 </a:solidFill>
@@ -31840,9 +31618,9 @@
                 <a:ea typeface="Cambria" pitchFamily="34" charset="-122"/>
                 <a:cs typeface="Cambria" pitchFamily="34" charset="-120"/>
               </a:rPr>
-              <a:t>Objetivos y funciones de la intubación endotraqueal</a:t>
-            </a:r>
-            <a:endParaRPr lang="en-US" sz="2700" dirty="0"/>
+              <a:t>Objetivos y funciones de la intubación</a:t>
+            </a:r>
+            <a:endParaRPr lang="en-US" sz="2500" dirty="0"/>
           </a:p>
         </p:txBody>
       </p:sp>
@@ -31973,8 +31751,8 @@
         </p:nvSpPr>
         <p:spPr>
           <a:xfrm>
-            <a:off x="1289304" y="2130552"/>
-            <a:ext cx="2624328" cy="1207008"/>
+            <a:off x="1289304" y="2386584"/>
+            <a:ext cx="2624328" cy="950976"/>
           </a:xfrm>
           <a:prstGeom prst="rect">
             <a:avLst/>
@@ -32137,8 +31915,8 @@
         </p:nvSpPr>
         <p:spPr>
           <a:xfrm>
-            <a:off x="5020056" y="2130552"/>
-            <a:ext cx="2624328" cy="1207008"/>
+            <a:off x="5020056" y="2112264"/>
+            <a:ext cx="2624328" cy="1225296"/>
           </a:xfrm>
           <a:prstGeom prst="rect">
             <a:avLst/>
@@ -32301,8 +32079,8 @@
         </p:nvSpPr>
         <p:spPr>
           <a:xfrm>
-            <a:off x="8750808" y="2130552"/>
-            <a:ext cx="2624328" cy="1207008"/>
+            <a:off x="8750808" y="2112264"/>
+            <a:ext cx="2624328" cy="1225296"/>
           </a:xfrm>
           <a:prstGeom prst="rect">
             <a:avLst/>
@@ -32465,8 +32243,8 @@
         </p:nvSpPr>
         <p:spPr>
           <a:xfrm>
-            <a:off x="1289304" y="4279392"/>
-            <a:ext cx="2624328" cy="1207008"/>
+            <a:off x="1289304" y="4261104"/>
+            <a:ext cx="2624328" cy="1225296"/>
           </a:xfrm>
           <a:prstGeom prst="rect">
             <a:avLst/>
@@ -32629,8 +32407,8 @@
         </p:nvSpPr>
         <p:spPr>
           <a:xfrm>
-            <a:off x="5020056" y="4279392"/>
-            <a:ext cx="2624328" cy="1207008"/>
+            <a:off x="5020056" y="4261104"/>
+            <a:ext cx="2624328" cy="1225296"/>
           </a:xfrm>
           <a:prstGeom prst="rect">
             <a:avLst/>
@@ -32793,8 +32571,8 @@
         </p:nvSpPr>
         <p:spPr>
           <a:xfrm>
-            <a:off x="8750808" y="4279392"/>
-            <a:ext cx="2624328" cy="1207008"/>
+            <a:off x="8750808" y="4261104"/>
+            <a:ext cx="2624328" cy="1225296"/>
           </a:xfrm>
           <a:prstGeom prst="rect">
             <a:avLst/>
@@ -33038,8 +32816,8 @@
         </p:nvSpPr>
         <p:spPr>
           <a:xfrm>
-            <a:off x="1252728" y="603504"/>
-            <a:ext cx="9966960" cy="548640"/>
+            <a:off x="1252728" y="621792"/>
+            <a:ext cx="10195560" cy="548640"/>
           </a:xfrm>
           <a:prstGeom prst="rect">
             <a:avLst/>
@@ -33055,7 +32833,7 @@
               <a:buNone/>
             </a:pPr>
             <a:r>
-              <a:rPr lang="en-US" sz="2700" b="1" dirty="0">
+              <a:rPr lang="en-US" sz="2500" b="1" dirty="0">
                 <a:solidFill>
                   <a:srgbClr val="2C3E50"/>
                 </a:solidFill>
@@ -33065,7 +32843,7 @@
               </a:rPr>
               <a:t>Cavidad nasal y cavidad oral</a:t>
             </a:r>
-            <a:endParaRPr lang="en-US" sz="2700" dirty="0"/>
+            <a:endParaRPr lang="en-US" sz="2500" dirty="0"/>
           </a:p>
         </p:txBody>
       </p:sp>
@@ -33196,8 +32974,8 @@
         </p:nvSpPr>
         <p:spPr>
           <a:xfrm>
-            <a:off x="1289304" y="2130552"/>
-            <a:ext cx="4517136" cy="3813048"/>
+            <a:off x="1289304" y="2112264"/>
+            <a:ext cx="4517136" cy="3831336"/>
           </a:xfrm>
           <a:prstGeom prst="rect">
             <a:avLst/>
@@ -33457,8 +33235,8 @@
         </p:nvSpPr>
         <p:spPr>
           <a:xfrm>
-            <a:off x="6958584" y="2130552"/>
-            <a:ext cx="4544568" cy="3813048"/>
+            <a:off x="6958584" y="2112264"/>
+            <a:ext cx="4544568" cy="3831336"/>
           </a:xfrm>
           <a:prstGeom prst="rect">
             <a:avLst/>
@@ -33799,8 +33577,8 @@
         </p:nvSpPr>
         <p:spPr>
           <a:xfrm>
-            <a:off x="1252728" y="603504"/>
-            <a:ext cx="9966960" cy="548640"/>
+            <a:off x="1252728" y="621792"/>
+            <a:ext cx="10195560" cy="548640"/>
           </a:xfrm>
           <a:prstGeom prst="rect">
             <a:avLst/>
@@ -33816,7 +33594,7 @@
               <a:buNone/>
             </a:pPr>
             <a:r>
-              <a:rPr lang="en-US" sz="2700" b="1" dirty="0">
+              <a:rPr lang="en-US" sz="2500" b="1" dirty="0">
                 <a:solidFill>
                   <a:srgbClr val="2C3E50"/>
                 </a:solidFill>
@@ -33824,9 +33602,9 @@
                 <a:ea typeface="Cambria" pitchFamily="34" charset="-122"/>
                 <a:cs typeface="Cambria" pitchFamily="34" charset="-120"/>
               </a:rPr>
-              <a:t>Faringe: nasofaringe, orofaringe e hipofaringe</a:t>
-            </a:r>
-            <a:endParaRPr lang="en-US" sz="2700" dirty="0"/>
+              <a:t>Faringe: naso, oro e hipofaringe</a:t>
+            </a:r>
+            <a:endParaRPr lang="en-US" sz="2500" dirty="0"/>
           </a:p>
         </p:txBody>
       </p:sp>
@@ -34893,8 +34671,8 @@
         </p:nvSpPr>
         <p:spPr>
           <a:xfrm>
-            <a:off x="1252728" y="603504"/>
-            <a:ext cx="9966960" cy="548640"/>
+            <a:off x="1252728" y="621792"/>
+            <a:ext cx="10195560" cy="548640"/>
           </a:xfrm>
           <a:prstGeom prst="rect">
             <a:avLst/>
@@ -34910,7 +34688,7 @@
               <a:buNone/>
             </a:pPr>
             <a:r>
-              <a:rPr lang="en-US" sz="2700" b="1" dirty="0">
+              <a:rPr lang="en-US" sz="2500" b="1" dirty="0">
                 <a:solidFill>
                   <a:srgbClr val="2C3E50"/>
                 </a:solidFill>
@@ -34918,9 +34696,9 @@
                 <a:ea typeface="Cambria" pitchFamily="34" charset="-122"/>
                 <a:cs typeface="Cambria" pitchFamily="34" charset="-120"/>
               </a:rPr>
-              <a:t>Laringe: cartílagos, glotis y cuerdas vocales</a:t>
-            </a:r>
-            <a:endParaRPr lang="en-US" sz="2700" dirty="0"/>
+              <a:t>Laringe: cartílagos y glotis</a:t>
+            </a:r>
+            <a:endParaRPr lang="en-US" sz="2500" dirty="0"/>
           </a:p>
         </p:txBody>
       </p:sp>
@@ -35051,8 +34829,8 @@
         </p:nvSpPr>
         <p:spPr>
           <a:xfrm>
-            <a:off x="1289304" y="2130552"/>
-            <a:ext cx="4425696" cy="3813048"/>
+            <a:off x="1289304" y="2112264"/>
+            <a:ext cx="4425696" cy="3831336"/>
           </a:xfrm>
           <a:prstGeom prst="rect">
             <a:avLst/>
@@ -35312,8 +35090,8 @@
         </p:nvSpPr>
         <p:spPr>
           <a:xfrm>
-            <a:off x="6867144" y="2130552"/>
-            <a:ext cx="4636008" cy="3813048"/>
+            <a:off x="6867144" y="2112264"/>
+            <a:ext cx="4636008" cy="3831336"/>
           </a:xfrm>
           <a:prstGeom prst="rect">
             <a:avLst/>
@@ -35654,8 +35432,8 @@
         </p:nvSpPr>
         <p:spPr>
           <a:xfrm>
-            <a:off x="1252728" y="603504"/>
-            <a:ext cx="9966960" cy="548640"/>
+            <a:off x="1252728" y="621792"/>
+            <a:ext cx="10195560" cy="548640"/>
           </a:xfrm>
           <a:prstGeom prst="rect">
             <a:avLst/>
@@ -35671,7 +35449,7 @@
               <a:buNone/>
             </a:pPr>
             <a:r>
-              <a:rPr lang="en-US" sz="2700" b="1" dirty="0">
+              <a:rPr lang="en-US" sz="2500" b="1" dirty="0">
                 <a:solidFill>
                   <a:srgbClr val="2C3E50"/>
                 </a:solidFill>
@@ -35681,7 +35459,7 @@
               </a:rPr>
               <a:t>Tráquea e inervación relevante</a:t>
             </a:r>
-            <a:endParaRPr lang="en-US" sz="2700" dirty="0"/>
+            <a:endParaRPr lang="en-US" sz="2500" dirty="0"/>
           </a:p>
         </p:txBody>
       </p:sp>
@@ -35812,8 +35590,8 @@
         </p:nvSpPr>
         <p:spPr>
           <a:xfrm>
-            <a:off x="1289304" y="2130552"/>
-            <a:ext cx="4425696" cy="3813048"/>
+            <a:off x="1289304" y="2112264"/>
+            <a:ext cx="4425696" cy="3831336"/>
           </a:xfrm>
           <a:prstGeom prst="rect">
             <a:avLst/>
@@ -36073,8 +35851,8 @@
         </p:nvSpPr>
         <p:spPr>
           <a:xfrm>
-            <a:off x="6867144" y="2130552"/>
-            <a:ext cx="4636008" cy="3813048"/>
+            <a:off x="6867144" y="2112264"/>
+            <a:ext cx="4636008" cy="3831336"/>
           </a:xfrm>
           <a:prstGeom prst="rect">
             <a:avLst/>

</xml_diff>